<commit_message>
fix(slides): preserve exact native aspect ratios on all diagrams and Retina screenshots
</commit_message>
<xml_diff>
--- a/slides/ws1-blog1-executive-diagrams.pptx
+++ b/slides/ws1-blog1-executive-diagrams.pptx
@@ -6299,9 +6299,45 @@
           </a:p>
         </p:txBody>
       </p:sp>
+      <p:sp>
+        <p:nvSpPr>
+          <p:cNvPr id="34" name="Text 32"/>
+          <p:cNvSpPr/>
+          <p:nvPr/>
+        </p:nvSpPr>
+        <p:spPr>
+          <a:xfrm>
+            <a:off x="685800" y="2596896"/>
+            <a:ext cx="5074920" cy="219456"/>
+          </a:xfrm>
+          <a:prstGeom prst="rect">
+            <a:avLst/>
+          </a:prstGeom>
+          <a:noFill/>
+          <a:ln/>
+        </p:spPr>
+        <p:txBody>
+          <a:bodyPr wrap="square" rtlCol="0" anchor="ctr"/>
+          <a:lstStyle/>
+          <a:p>
+            <a:pPr algn="ctr" indent="0" marL="0">
+              <a:buNone/>
+            </a:pPr>
+            <a:r>
+              <a:rPr lang="en-US" sz="850" b="1" dirty="0">
+                <a:solidFill>
+                  <a:srgbClr val="D93025"/>
+                </a:solidFill>
+              </a:rPr>
+              <a:t>BEFORE: All Tenants Exposed</a:t>
+            </a:r>
+            <a:endParaRPr lang="en-US" sz="850" dirty="0"/>
+          </a:p>
+        </p:txBody>
+      </p:sp>
       <p:pic>
         <p:nvPicPr>
-          <p:cNvPr id="34" name="Image 0" descr="/usr/local/google/home/nitinagga/Documents/blogs/screenshots/genuine-multicloud-3p-uis/before-after/before_01_metabase_bi.png">    </p:cNvPr>
+          <p:cNvPr id="35" name="Image 0" descr="/usr/local/google/home/nitinagga/Documents/blogs/screenshots/genuine-multicloud-3p-uis/before-after/before_01_metabase_bi.png">    </p:cNvPr>
           <p:cNvPicPr>
             <a:picLocks noChangeAspect="1"/>
           </p:cNvPicPr>
@@ -6309,13 +6345,14 @@
         </p:nvPicPr>
         <p:blipFill>
           <a:blip r:embed="rId1"/>
-          <a:srcRect l="0" r="0" t="0" b="0"/>
-          <a:stretch/>
+          <a:stretch>
+            <a:fillRect/>
+          </a:stretch>
         </p:blipFill>
         <p:spPr>
           <a:xfrm>
-            <a:off x="685800" y="2889504"/>
-            <a:ext cx="2423160" cy="3246120"/>
+            <a:off x="1965046" y="2816352"/>
+            <a:ext cx="2516429" cy="1572768"/>
           </a:xfrm>
           <a:prstGeom prst="rect">
             <a:avLst/>
@@ -6324,14 +6361,38 @@
       </p:pic>
       <p:sp>
         <p:nvSpPr>
-          <p:cNvPr id="35" name="Text 32"/>
-          <p:cNvSpPr/>
-          <p:nvPr/>
-        </p:nvSpPr>
-        <p:spPr>
-          <a:xfrm>
-            <a:off x="685800" y="2615184"/>
-            <a:ext cx="2423160" cy="237744"/>
+          <p:cNvPr id="36" name="Shape 33"/>
+          <p:cNvSpPr/>
+          <p:nvPr/>
+        </p:nvSpPr>
+        <p:spPr>
+          <a:xfrm>
+            <a:off x="3218688" y="4407408"/>
+            <a:ext cx="0" cy="201168"/>
+          </a:xfrm>
+          <a:prstGeom prst="line">
+            <a:avLst/>
+          </a:prstGeom>
+          <a:noFill/>
+          <a:ln w="27940">
+            <a:solidFill>
+              <a:srgbClr val="1E8E3E"/>
+            </a:solidFill>
+            <a:prstDash val="solid"/>
+            <a:tailEnd type="arrow"/>
+          </a:ln>
+        </p:spPr>
+      </p:sp>
+      <p:sp>
+        <p:nvSpPr>
+          <p:cNvPr id="37" name="Text 34"/>
+          <p:cNvSpPr/>
+          <p:nvPr/>
+        </p:nvSpPr>
+        <p:spPr>
+          <a:xfrm>
+            <a:off x="685800" y="4608576"/>
+            <a:ext cx="5074920" cy="219456"/>
           </a:xfrm>
           <a:prstGeom prst="rect">
             <a:avLst/>
@@ -6349,42 +6410,18 @@
             <a:r>
               <a:rPr lang="en-US" sz="850" b="1" dirty="0">
                 <a:solidFill>
-                  <a:srgbClr val="D93025"/>
-                </a:solidFill>
-              </a:rPr>
-              <a:t>BEFORE: All Tenants Exposed</a:t>
+                  <a:srgbClr val="1E8E3E"/>
+                </a:solidFill>
+              </a:rPr>
+              <a:t>AFTER: FinVault Only (0 Leaks)</a:t>
             </a:r>
             <a:endParaRPr lang="en-US" sz="850" dirty="0"/>
           </a:p>
         </p:txBody>
-      </p:sp>
-      <p:sp>
-        <p:nvSpPr>
-          <p:cNvPr id="36" name="Shape 33"/>
-          <p:cNvSpPr/>
-          <p:nvPr/>
-        </p:nvSpPr>
-        <p:spPr>
-          <a:xfrm>
-            <a:off x="3127248" y="4480560"/>
-            <a:ext cx="237744" cy="0"/>
-          </a:xfrm>
-          <a:prstGeom prst="line">
-            <a:avLst/>
-          </a:prstGeom>
-          <a:noFill/>
-          <a:ln w="27940">
-            <a:solidFill>
-              <a:srgbClr val="1E8E3E"/>
-            </a:solidFill>
-            <a:prstDash val="solid"/>
-            <a:tailEnd type="arrow"/>
-          </a:ln>
-        </p:spPr>
       </p:sp>
       <p:pic>
         <p:nvPicPr>
-          <p:cNvPr id="37" name="Image 1" descr="/usr/local/google/home/nitinagga/Documents/blogs/screenshots/genuine-multicloud-3p-uis/before-after/after_01_metabase_bi.png">    </p:cNvPr>
+          <p:cNvPr id="38" name="Image 1" descr="/usr/local/google/home/nitinagga/Documents/blogs/screenshots/genuine-multicloud-3p-uis/before-after/after_01_metabase_bi.png">    </p:cNvPr>
           <p:cNvPicPr>
             <a:picLocks noChangeAspect="1"/>
           </p:cNvPicPr>
@@ -6392,55 +6429,20 @@
         </p:nvPicPr>
         <p:blipFill>
           <a:blip r:embed="rId2"/>
-          <a:srcRect l="0" r="0" t="0" b="0"/>
-          <a:stretch/>
+          <a:stretch>
+            <a:fillRect/>
+          </a:stretch>
         </p:blipFill>
         <p:spPr>
           <a:xfrm>
-            <a:off x="3383280" y="2889504"/>
-            <a:ext cx="2423160" cy="3246120"/>
+            <a:off x="2067458" y="4828032"/>
+            <a:ext cx="2311603" cy="1444752"/>
           </a:xfrm>
           <a:prstGeom prst="rect">
             <a:avLst/>
           </a:prstGeom>
         </p:spPr>
       </p:pic>
-      <p:sp>
-        <p:nvSpPr>
-          <p:cNvPr id="38" name="Text 34"/>
-          <p:cNvSpPr/>
-          <p:nvPr/>
-        </p:nvSpPr>
-        <p:spPr>
-          <a:xfrm>
-            <a:off x="3383280" y="2615184"/>
-            <a:ext cx="2423160" cy="237744"/>
-          </a:xfrm>
-          <a:prstGeom prst="rect">
-            <a:avLst/>
-          </a:prstGeom>
-          <a:noFill/>
-          <a:ln/>
-        </p:spPr>
-        <p:txBody>
-          <a:bodyPr wrap="square" rtlCol="0" anchor="ctr"/>
-          <a:lstStyle/>
-          <a:p>
-            <a:pPr algn="ctr" indent="0" marL="0">
-              <a:buNone/>
-            </a:pPr>
-            <a:r>
-              <a:rPr lang="en-US" sz="850" b="1" dirty="0">
-                <a:solidFill>
-                  <a:srgbClr val="1E8E3E"/>
-                </a:solidFill>
-              </a:rPr>
-              <a:t>AFTER: FinVault Only (0 Leaks)</a:t>
-            </a:r>
-            <a:endParaRPr lang="en-US" sz="850" dirty="0"/>
-          </a:p>
-        </p:txBody>
-      </p:sp>
       <p:sp>
         <p:nvSpPr>
           <p:cNvPr id="39" name="Shape 35"/>
@@ -6507,9 +6509,45 @@
           </a:p>
         </p:txBody>
       </p:sp>
+      <p:sp>
+        <p:nvSpPr>
+          <p:cNvPr id="41" name="Text 37"/>
+          <p:cNvSpPr/>
+          <p:nvPr/>
+        </p:nvSpPr>
+        <p:spPr>
+          <a:xfrm>
+            <a:off x="6428232" y="2596896"/>
+            <a:ext cx="5074920" cy="219456"/>
+          </a:xfrm>
+          <a:prstGeom prst="rect">
+            <a:avLst/>
+          </a:prstGeom>
+          <a:noFill/>
+          <a:ln/>
+        </p:spPr>
+        <p:txBody>
+          <a:bodyPr wrap="square" rtlCol="0" anchor="ctr"/>
+          <a:lstStyle/>
+          <a:p>
+            <a:pPr algn="ctr" indent="0" marL="0">
+              <a:buNone/>
+            </a:pPr>
+            <a:r>
+              <a:rPr lang="en-US" sz="850" b="1" dirty="0">
+                <a:solidFill>
+                  <a:srgbClr val="D93025"/>
+                </a:solidFill>
+              </a:rPr>
+              <a:t>BEFORE: Cross-Tenant Enumeration</a:t>
+            </a:r>
+            <a:endParaRPr lang="en-US" sz="850" dirty="0"/>
+          </a:p>
+        </p:txBody>
+      </p:sp>
       <p:pic>
         <p:nvPicPr>
-          <p:cNvPr id="41" name="Image 2" descr="/usr/local/google/home/nitinagga/Documents/blogs/screenshots/genuine-multicloud-3p-uis/before-after/before_06_trino_sql.png">    </p:cNvPr>
+          <p:cNvPr id="42" name="Image 2" descr="/usr/local/google/home/nitinagga/Documents/blogs/screenshots/genuine-multicloud-3p-uis/before-after/before_06_trino_sql.png">    </p:cNvPr>
           <p:cNvPicPr>
             <a:picLocks noChangeAspect="1"/>
           </p:cNvPicPr>
@@ -6517,13 +6555,14 @@
         </p:nvPicPr>
         <p:blipFill>
           <a:blip r:embed="rId3"/>
-          <a:srcRect l="0" r="0" t="0" b="0"/>
-          <a:stretch/>
+          <a:stretch>
+            <a:fillRect/>
+          </a:stretch>
         </p:blipFill>
         <p:spPr>
           <a:xfrm>
-            <a:off x="6428232" y="2889504"/>
-            <a:ext cx="2423160" cy="3246120"/>
+            <a:off x="7707478" y="2816352"/>
+            <a:ext cx="2516429" cy="1572768"/>
           </a:xfrm>
           <a:prstGeom prst="rect">
             <a:avLst/>
@@ -6532,14 +6571,38 @@
       </p:pic>
       <p:sp>
         <p:nvSpPr>
-          <p:cNvPr id="42" name="Text 37"/>
-          <p:cNvSpPr/>
-          <p:nvPr/>
-        </p:nvSpPr>
-        <p:spPr>
-          <a:xfrm>
-            <a:off x="6428232" y="2615184"/>
-            <a:ext cx="2423160" cy="237744"/>
+          <p:cNvPr id="43" name="Shape 38"/>
+          <p:cNvSpPr/>
+          <p:nvPr/>
+        </p:nvSpPr>
+        <p:spPr>
+          <a:xfrm>
+            <a:off x="8961120" y="4407408"/>
+            <a:ext cx="0" cy="201168"/>
+          </a:xfrm>
+          <a:prstGeom prst="line">
+            <a:avLst/>
+          </a:prstGeom>
+          <a:noFill/>
+          <a:ln w="27940">
+            <a:solidFill>
+              <a:srgbClr val="1E8E3E"/>
+            </a:solidFill>
+            <a:prstDash val="solid"/>
+            <a:tailEnd type="arrow"/>
+          </a:ln>
+        </p:spPr>
+      </p:sp>
+      <p:sp>
+        <p:nvSpPr>
+          <p:cNvPr id="44" name="Text 39"/>
+          <p:cNvSpPr/>
+          <p:nvPr/>
+        </p:nvSpPr>
+        <p:spPr>
+          <a:xfrm>
+            <a:off x="6428232" y="4608576"/>
+            <a:ext cx="5074920" cy="219456"/>
           </a:xfrm>
           <a:prstGeom prst="rect">
             <a:avLst/>
@@ -6557,42 +6620,18 @@
             <a:r>
               <a:rPr lang="en-US" sz="850" b="1" dirty="0">
                 <a:solidFill>
-                  <a:srgbClr val="D93025"/>
-                </a:solidFill>
-              </a:rPr>
-              <a:t>BEFORE: Cross-Tenant Enumeration</a:t>
+                  <a:srgbClr val="1E8E3E"/>
+                </a:solidFill>
+              </a:rPr>
+              <a:t>AFTER: Scoped Query (0 Leaks)</a:t>
             </a:r>
             <a:endParaRPr lang="en-US" sz="850" dirty="0"/>
           </a:p>
         </p:txBody>
-      </p:sp>
-      <p:sp>
-        <p:nvSpPr>
-          <p:cNvPr id="43" name="Shape 38"/>
-          <p:cNvSpPr/>
-          <p:nvPr/>
-        </p:nvSpPr>
-        <p:spPr>
-          <a:xfrm>
-            <a:off x="8869680" y="4480560"/>
-            <a:ext cx="237744" cy="0"/>
-          </a:xfrm>
-          <a:prstGeom prst="line">
-            <a:avLst/>
-          </a:prstGeom>
-          <a:noFill/>
-          <a:ln w="27940">
-            <a:solidFill>
-              <a:srgbClr val="1E8E3E"/>
-            </a:solidFill>
-            <a:prstDash val="solid"/>
-            <a:tailEnd type="arrow"/>
-          </a:ln>
-        </p:spPr>
       </p:sp>
       <p:pic>
         <p:nvPicPr>
-          <p:cNvPr id="44" name="Image 3" descr="/usr/local/google/home/nitinagga/Documents/blogs/screenshots/genuine-multicloud-3p-uis/before-after/after_06_trino_sql.png">    </p:cNvPr>
+          <p:cNvPr id="45" name="Image 3" descr="/usr/local/google/home/nitinagga/Documents/blogs/screenshots/genuine-multicloud-3p-uis/before-after/after_06_trino_sql.png">    </p:cNvPr>
           <p:cNvPicPr>
             <a:picLocks noChangeAspect="1"/>
           </p:cNvPicPr>
@@ -6600,55 +6639,20 @@
         </p:nvPicPr>
         <p:blipFill>
           <a:blip r:embed="rId4"/>
-          <a:srcRect l="0" r="0" t="0" b="0"/>
-          <a:stretch/>
+          <a:stretch>
+            <a:fillRect/>
+          </a:stretch>
         </p:blipFill>
         <p:spPr>
           <a:xfrm>
-            <a:off x="9125712" y="2889504"/>
-            <a:ext cx="2423160" cy="3246120"/>
+            <a:off x="7809890" y="4828032"/>
+            <a:ext cx="2311603" cy="1444752"/>
           </a:xfrm>
           <a:prstGeom prst="rect">
             <a:avLst/>
           </a:prstGeom>
         </p:spPr>
       </p:pic>
-      <p:sp>
-        <p:nvSpPr>
-          <p:cNvPr id="45" name="Text 39"/>
-          <p:cNvSpPr/>
-          <p:nvPr/>
-        </p:nvSpPr>
-        <p:spPr>
-          <a:xfrm>
-            <a:off x="9125712" y="2615184"/>
-            <a:ext cx="2423160" cy="237744"/>
-          </a:xfrm>
-          <a:prstGeom prst="rect">
-            <a:avLst/>
-          </a:prstGeom>
-          <a:noFill/>
-          <a:ln/>
-        </p:spPr>
-        <p:txBody>
-          <a:bodyPr wrap="square" rtlCol="0" anchor="ctr"/>
-          <a:lstStyle/>
-          <a:p>
-            <a:pPr algn="ctr" indent="0" marL="0">
-              <a:buNone/>
-            </a:pPr>
-            <a:r>
-              <a:rPr lang="en-US" sz="850" b="1" dirty="0">
-                <a:solidFill>
-                  <a:srgbClr val="1E8E3E"/>
-                </a:solidFill>
-              </a:rPr>
-              <a:t>AFTER: Scoped Query (0 Leaks)</a:t>
-            </a:r>
-            <a:endParaRPr lang="en-US" sz="850" dirty="0"/>
-          </a:p>
-        </p:txBody>
-      </p:sp>
     </p:spTree>
   </p:cSld>
   <p:clrMapOvr>
@@ -20772,13 +20776,14 @@
         </p:nvPicPr>
         <p:blipFill>
           <a:blip r:embed="rId1"/>
-          <a:srcRect l="0" r="0" t="0" b="0"/>
-          <a:stretch/>
+          <a:stretch>
+            <a:fillRect/>
+          </a:stretch>
         </p:blipFill>
         <p:spPr>
           <a:xfrm>
-            <a:off x="621792" y="1152144"/>
-            <a:ext cx="8129016" cy="5138928"/>
+            <a:off x="2499970" y="1152144"/>
+            <a:ext cx="4373575" cy="5138928"/>
           </a:xfrm>
           <a:prstGeom prst="rect">
             <a:avLst/>
@@ -21796,13 +21801,14 @@
         </p:nvPicPr>
         <p:blipFill>
           <a:blip r:embed="rId1"/>
-          <a:srcRect l="0" r="0" t="0" b="0"/>
-          <a:stretch/>
+          <a:stretch>
+            <a:fillRect/>
+          </a:stretch>
         </p:blipFill>
         <p:spPr>
           <a:xfrm>
-            <a:off x="621792" y="1152144"/>
-            <a:ext cx="8129016" cy="5138928"/>
+            <a:off x="2499970" y="1152144"/>
+            <a:ext cx="4373575" cy="5138928"/>
           </a:xfrm>
           <a:prstGeom prst="rect">
             <a:avLst/>

</xml_diff>

<commit_message>
feat(slides): convert Slides 7 and 8 to 100% native editable Google Slides shapes and arrows
</commit_message>
<xml_diff>
--- a/slides/ws1-blog1-executive-diagrams.pptx
+++ b/slides/ws1-blog1-executive-diagrams.pptx
@@ -20543,7 +20543,7 @@
                 <a:ea typeface="Google Sans Display" pitchFamily="34" charset="-122"/>
                 <a:cs typeface="Google Sans Display" pitchFamily="34" charset="-120"/>
               </a:rPr>
-              <a:t>56 Shapes • 23 Edges</a:t>
+              <a:t>100% Native Editable</a:t>
             </a:r>
             <a:endParaRPr lang="en-US" sz="950" dirty="0"/>
           </a:p>
@@ -20758,41 +20758,2016 @@
           <a:solidFill>
             <a:srgbClr val="FFFFFF"/>
           </a:solidFill>
-          <a:ln w="15240">
-            <a:solidFill>
-              <a:srgbClr val="CBD5E1"/>
-            </a:solidFill>
-            <a:prstDash val="solid"/>
-          </a:ln>
-        </p:spPr>
-      </p:sp>
-      <p:pic>
-        <p:nvPicPr>
-          <p:cNvPr id="17" name="Image 0" descr="/usr/local/google/home/nitinagga/Documents/blogs/diagrams/ws1-multi-tenant-taxonomy-overview.drawio.png">    </p:cNvPr>
-          <p:cNvPicPr>
-            <a:picLocks noChangeAspect="1"/>
-          </p:cNvPicPr>
-          <p:nvPr/>
-        </p:nvPicPr>
-        <p:blipFill>
-          <a:blip r:embed="rId1"/>
-          <a:stretch>
-            <a:fillRect/>
-          </a:stretch>
-        </p:blipFill>
-        <p:spPr>
-          <a:xfrm>
-            <a:off x="2499970" y="1152144"/>
-            <a:ext cx="4373575" cy="5138928"/>
-          </a:xfrm>
-          <a:prstGeom prst="rect">
-            <a:avLst/>
-          </a:prstGeom>
-        </p:spPr>
-      </p:pic>
-      <p:sp>
-        <p:nvSpPr>
-          <p:cNvPr id="18" name="Shape 15"/>
+          <a:ln w="22225">
+            <a:solidFill>
+              <a:srgbClr val="1A73E8"/>
+            </a:solidFill>
+            <a:prstDash val="solid"/>
+          </a:ln>
+        </p:spPr>
+      </p:sp>
+      <p:sp>
+        <p:nvSpPr>
+          <p:cNvPr id="17" name="Text 15"/>
+          <p:cNvSpPr/>
+          <p:nvPr/>
+        </p:nvSpPr>
+        <p:spPr>
+          <a:xfrm>
+            <a:off x="685800" y="1133856"/>
+            <a:ext cx="8001000" cy="256032"/>
+          </a:xfrm>
+          <a:prstGeom prst="rect">
+            <a:avLst/>
+          </a:prstGeom>
+          <a:noFill/>
+          <a:ln/>
+        </p:spPr>
+        <p:txBody>
+          <a:bodyPr wrap="square" rtlCol="0" anchor="ctr"/>
+          <a:lstStyle/>
+          <a:p>
+            <a:pPr indent="0" marL="0">
+              <a:buNone/>
+            </a:pPr>
+            <a:r>
+              <a:rPr lang="en-US" sz="950" b="1" dirty="0">
+                <a:solidFill>
+                  <a:srgbClr val="1A73E8"/>
+                </a:solidFill>
+                <a:latin typeface="Google Sans Display" pitchFamily="34" charset="0"/>
+                <a:ea typeface="Google Sans Display" pitchFamily="34" charset="-122"/>
+                <a:cs typeface="Google Sans Display" pitchFamily="34" charset="-120"/>
+              </a:rPr>
+              <a:t>Google Cloud • Shared Control Plane &amp; Isolated Execution Spokes</a:t>
+            </a:r>
+            <a:endParaRPr lang="en-US" sz="950" dirty="0"/>
+          </a:p>
+        </p:txBody>
+      </p:sp>
+      <p:sp>
+        <p:nvSpPr>
+          <p:cNvPr id="18" name="Shape 16"/>
+          <p:cNvSpPr/>
+          <p:nvPr/>
+        </p:nvSpPr>
+        <p:spPr>
+          <a:xfrm>
+            <a:off x="685800" y="1444752"/>
+            <a:ext cx="4892040" cy="2057400"/>
+          </a:xfrm>
+          <a:prstGeom prst="roundRect">
+            <a:avLst>
+              <a:gd name="adj" fmla="val 3556"/>
+            </a:avLst>
+          </a:prstGeom>
+          <a:solidFill>
+            <a:srgbClr val="E8F0FE"/>
+          </a:solidFill>
+          <a:ln w="17780">
+            <a:solidFill>
+              <a:srgbClr val="1A73E8"/>
+            </a:solidFill>
+            <a:prstDash val="solid"/>
+          </a:ln>
+        </p:spPr>
+      </p:sp>
+      <p:sp>
+        <p:nvSpPr>
+          <p:cNvPr id="19" name="Text 17"/>
+          <p:cNvSpPr/>
+          <p:nvPr/>
+        </p:nvSpPr>
+        <p:spPr>
+          <a:xfrm>
+            <a:off x="822960" y="1499616"/>
+            <a:ext cx="4617720" cy="237744"/>
+          </a:xfrm>
+          <a:prstGeom prst="rect">
+            <a:avLst/>
+          </a:prstGeom>
+          <a:noFill/>
+          <a:ln/>
+        </p:spPr>
+        <p:txBody>
+          <a:bodyPr wrap="square" rtlCol="0" anchor="ctr"/>
+          <a:lstStyle/>
+          <a:p>
+            <a:pPr indent="0" marL="0">
+              <a:buNone/>
+            </a:pPr>
+            <a:r>
+              <a:rPr lang="en-US" sz="950" b="1" dirty="0">
+                <a:solidFill>
+                  <a:srgbClr val="1A73E8"/>
+                </a:solidFill>
+                <a:latin typeface="Google Sans Display" pitchFamily="34" charset="0"/>
+                <a:ea typeface="Google Sans Display" pitchFamily="34" charset="-122"/>
+                <a:cs typeface="Google Sans Display" pitchFamily="34" charset="-120"/>
+              </a:rPr>
+              <a:t>1. Blue Routing Hub (Hops 1 &amp; 2 Ingress)</a:t>
+            </a:r>
+            <a:endParaRPr lang="en-US" sz="950" dirty="0"/>
+          </a:p>
+        </p:txBody>
+      </p:sp>
+      <p:sp>
+        <p:nvSpPr>
+          <p:cNvPr id="20" name="Shape 18"/>
+          <p:cNvSpPr/>
+          <p:nvPr/>
+        </p:nvSpPr>
+        <p:spPr>
+          <a:xfrm>
+            <a:off x="822960" y="1810512"/>
+            <a:ext cx="1463040" cy="694944"/>
+          </a:xfrm>
+          <a:prstGeom prst="roundRect">
+            <a:avLst>
+              <a:gd name="adj" fmla="val 7895"/>
+            </a:avLst>
+          </a:prstGeom>
+          <a:solidFill>
+            <a:srgbClr val="FFFFFF"/>
+          </a:solidFill>
+          <a:ln w="12700">
+            <a:solidFill>
+              <a:srgbClr val="1A73E8"/>
+            </a:solidFill>
+            <a:prstDash val="solid"/>
+          </a:ln>
+        </p:spPr>
+      </p:sp>
+      <p:sp>
+        <p:nvSpPr>
+          <p:cNvPr id="21" name="Text 19"/>
+          <p:cNvSpPr/>
+          <p:nvPr/>
+        </p:nvSpPr>
+        <p:spPr>
+          <a:xfrm>
+            <a:off x="859536" y="1810512"/>
+            <a:ext cx="1389888" cy="694944"/>
+          </a:xfrm>
+          <a:prstGeom prst="rect">
+            <a:avLst/>
+          </a:prstGeom>
+          <a:noFill/>
+          <a:ln/>
+        </p:spPr>
+        <p:txBody>
+          <a:bodyPr wrap="square" rtlCol="0" anchor="ctr"/>
+          <a:lstStyle/>
+          <a:p>
+            <a:pPr algn="ctr" indent="0" marL="0">
+              <a:buNone/>
+            </a:pPr>
+            <a:r>
+              <a:rPr lang="en-US" sz="820" b="1" dirty="0">
+                <a:solidFill>
+                  <a:srgbClr val="0F172A"/>
+                </a:solidFill>
+                <a:latin typeface="Google Sans Text" pitchFamily="34" charset="0"/>
+                <a:ea typeface="Google Sans Text" pitchFamily="34" charset="-122"/>
+                <a:cs typeface="Google Sans Text" pitchFamily="34" charset="-120"/>
+              </a:rPr>
+              <a:t>Cloud Armor WAF</a:t>
+            </a:r>
+            <a:endParaRPr lang="en-US" sz="820" dirty="0"/>
+          </a:p>
+          <a:p>
+            <a:pPr algn="ctr" indent="0" marL="0">
+              <a:buNone/>
+            </a:pPr>
+            <a:r>
+              <a:rPr lang="en-US" sz="820" b="1" dirty="0">
+                <a:solidFill>
+                  <a:srgbClr val="0F172A"/>
+                </a:solidFill>
+                <a:latin typeface="Google Sans Text" pitchFamily="34" charset="0"/>
+                <a:ea typeface="Google Sans Text" pitchFamily="34" charset="-122"/>
+                <a:cs typeface="Google Sans Text" pitchFamily="34" charset="-120"/>
+              </a:rPr>
+              <a:t>Strips X-Tenant-Id</a:t>
+            </a:r>
+            <a:endParaRPr lang="en-US" sz="820" dirty="0"/>
+          </a:p>
+        </p:txBody>
+      </p:sp>
+      <p:sp>
+        <p:nvSpPr>
+          <p:cNvPr id="22" name="Shape 20"/>
+          <p:cNvSpPr/>
+          <p:nvPr/>
+        </p:nvSpPr>
+        <p:spPr>
+          <a:xfrm>
+            <a:off x="2395728" y="1810512"/>
+            <a:ext cx="1463040" cy="694944"/>
+          </a:xfrm>
+          <a:prstGeom prst="roundRect">
+            <a:avLst>
+              <a:gd name="adj" fmla="val 7895"/>
+            </a:avLst>
+          </a:prstGeom>
+          <a:solidFill>
+            <a:srgbClr val="FFFFFF"/>
+          </a:solidFill>
+          <a:ln w="12700">
+            <a:solidFill>
+              <a:srgbClr val="1A73E8"/>
+            </a:solidFill>
+            <a:prstDash val="solid"/>
+          </a:ln>
+        </p:spPr>
+      </p:sp>
+      <p:sp>
+        <p:nvSpPr>
+          <p:cNvPr id="23" name="Text 21"/>
+          <p:cNvSpPr/>
+          <p:nvPr/>
+        </p:nvSpPr>
+        <p:spPr>
+          <a:xfrm>
+            <a:off x="2432304" y="1810512"/>
+            <a:ext cx="1389888" cy="694944"/>
+          </a:xfrm>
+          <a:prstGeom prst="rect">
+            <a:avLst/>
+          </a:prstGeom>
+          <a:noFill/>
+          <a:ln/>
+        </p:spPr>
+        <p:txBody>
+          <a:bodyPr wrap="square" rtlCol="0" anchor="ctr"/>
+          <a:lstStyle/>
+          <a:p>
+            <a:pPr algn="ctr" indent="0" marL="0">
+              <a:buNone/>
+            </a:pPr>
+            <a:r>
+              <a:rPr lang="en-US" sz="820" b="1" dirty="0">
+                <a:solidFill>
+                  <a:srgbClr val="0F172A"/>
+                </a:solidFill>
+                <a:latin typeface="Google Sans Text" pitchFamily="34" charset="0"/>
+                <a:ea typeface="Google Sans Text" pitchFamily="34" charset="-122"/>
+                <a:cs typeface="Google Sans Text" pitchFamily="34" charset="-120"/>
+              </a:rPr>
+              <a:t>External ALB</a:t>
+            </a:r>
+            <a:endParaRPr lang="en-US" sz="820" dirty="0"/>
+          </a:p>
+          <a:p>
+            <a:pPr algn="ctr" indent="0" marL="0">
+              <a:buNone/>
+            </a:pPr>
+            <a:r>
+              <a:rPr lang="en-US" sz="820" b="1" dirty="0">
+                <a:solidFill>
+                  <a:srgbClr val="0F172A"/>
+                </a:solidFill>
+                <a:latin typeface="Google Sans Text" pitchFamily="34" charset="0"/>
+                <a:ea typeface="Google Sans Text" pitchFamily="34" charset="-122"/>
+                <a:cs typeface="Google Sans Text" pitchFamily="34" charset="-120"/>
+              </a:rPr>
+              <a:t>Global Anycast TLS</a:t>
+            </a:r>
+            <a:endParaRPr lang="en-US" sz="820" dirty="0"/>
+          </a:p>
+        </p:txBody>
+      </p:sp>
+      <p:sp>
+        <p:nvSpPr>
+          <p:cNvPr id="24" name="Shape 22"/>
+          <p:cNvSpPr/>
+          <p:nvPr/>
+        </p:nvSpPr>
+        <p:spPr>
+          <a:xfrm>
+            <a:off x="3968496" y="1810512"/>
+            <a:ext cx="1463040" cy="694944"/>
+          </a:xfrm>
+          <a:prstGeom prst="roundRect">
+            <a:avLst>
+              <a:gd name="adj" fmla="val 7895"/>
+            </a:avLst>
+          </a:prstGeom>
+          <a:solidFill>
+            <a:srgbClr val="FFFFFF"/>
+          </a:solidFill>
+          <a:ln w="12700">
+            <a:solidFill>
+              <a:srgbClr val="1A73E8"/>
+            </a:solidFill>
+            <a:prstDash val="solid"/>
+          </a:ln>
+        </p:spPr>
+      </p:sp>
+      <p:sp>
+        <p:nvSpPr>
+          <p:cNvPr id="25" name="Text 23"/>
+          <p:cNvSpPr/>
+          <p:nvPr/>
+        </p:nvSpPr>
+        <p:spPr>
+          <a:xfrm>
+            <a:off x="4005072" y="1810512"/>
+            <a:ext cx="1389888" cy="694944"/>
+          </a:xfrm>
+          <a:prstGeom prst="rect">
+            <a:avLst/>
+          </a:prstGeom>
+          <a:noFill/>
+          <a:ln/>
+        </p:spPr>
+        <p:txBody>
+          <a:bodyPr wrap="square" rtlCol="0" anchor="ctr"/>
+          <a:lstStyle/>
+          <a:p>
+            <a:pPr algn="ctr" indent="0" marL="0">
+              <a:buNone/>
+            </a:pPr>
+            <a:r>
+              <a:rPr lang="en-US" sz="820" b="1" dirty="0">
+                <a:solidFill>
+                  <a:srgbClr val="0F172A"/>
+                </a:solidFill>
+                <a:latin typeface="Google Sans Text" pitchFamily="34" charset="0"/>
+                <a:ea typeface="Google Sans Text" pitchFamily="34" charset="-122"/>
+                <a:cs typeface="Google Sans Text" pitchFamily="34" charset="-120"/>
+              </a:rPr>
+              <a:t>IAP + STS Signer</a:t>
+            </a:r>
+            <a:endParaRPr lang="en-US" sz="820" dirty="0"/>
+          </a:p>
+          <a:p>
+            <a:pPr algn="ctr" indent="0" marL="0">
+              <a:buNone/>
+            </a:pPr>
+            <a:r>
+              <a:rPr lang="en-US" sz="820" b="1" dirty="0">
+                <a:solidFill>
+                  <a:srgbClr val="0F172A"/>
+                </a:solidFill>
+                <a:latin typeface="Google Sans Text" pitchFamily="34" charset="0"/>
+                <a:ea typeface="Google Sans Text" pitchFamily="34" charset="-122"/>
+                <a:cs typeface="Google Sans Text" pitchFamily="34" charset="-120"/>
+              </a:rPr>
+              <a:t>OIDC + DPoP -&gt; JWT</a:t>
+            </a:r>
+            <a:endParaRPr lang="en-US" sz="820" dirty="0"/>
+          </a:p>
+        </p:txBody>
+      </p:sp>
+      <p:sp>
+        <p:nvSpPr>
+          <p:cNvPr id="26" name="Shape 24"/>
+          <p:cNvSpPr/>
+          <p:nvPr/>
+        </p:nvSpPr>
+        <p:spPr>
+          <a:xfrm>
+            <a:off x="822960" y="2651760"/>
+            <a:ext cx="1463040" cy="694944"/>
+          </a:xfrm>
+          <a:prstGeom prst="roundRect">
+            <a:avLst>
+              <a:gd name="adj" fmla="val 7895"/>
+            </a:avLst>
+          </a:prstGeom>
+          <a:solidFill>
+            <a:srgbClr val="FFFFFF"/>
+          </a:solidFill>
+          <a:ln w="12700">
+            <a:solidFill>
+              <a:srgbClr val="1A73E8"/>
+            </a:solidFill>
+            <a:prstDash val="solid"/>
+          </a:ln>
+        </p:spPr>
+      </p:sp>
+      <p:sp>
+        <p:nvSpPr>
+          <p:cNvPr id="27" name="Text 25"/>
+          <p:cNvSpPr/>
+          <p:nvPr/>
+        </p:nvSpPr>
+        <p:spPr>
+          <a:xfrm>
+            <a:off x="859536" y="2651760"/>
+            <a:ext cx="1389888" cy="694944"/>
+          </a:xfrm>
+          <a:prstGeom prst="rect">
+            <a:avLst/>
+          </a:prstGeom>
+          <a:noFill/>
+          <a:ln/>
+        </p:spPr>
+        <p:txBody>
+          <a:bodyPr wrap="square" rtlCol="0" anchor="ctr"/>
+          <a:lstStyle/>
+          <a:p>
+            <a:pPr algn="ctr" indent="0" marL="0">
+              <a:buNone/>
+            </a:pPr>
+            <a:r>
+              <a:rPr lang="en-US" sz="820" b="1" dirty="0">
+                <a:solidFill>
+                  <a:srgbClr val="0F172A"/>
+                </a:solidFill>
+                <a:latin typeface="Google Sans Text" pitchFamily="34" charset="0"/>
+                <a:ea typeface="Google Sans Text" pitchFamily="34" charset="-122"/>
+                <a:cs typeface="Google Sans Text" pitchFamily="34" charset="-120"/>
+              </a:rPr>
+              <a:t>Model Armor Edge</a:t>
+            </a:r>
+            <a:endParaRPr lang="en-US" sz="820" dirty="0"/>
+          </a:p>
+          <a:p>
+            <a:pPr algn="ctr" indent="0" marL="0">
+              <a:buNone/>
+            </a:pPr>
+            <a:r>
+              <a:rPr lang="en-US" sz="820" b="1" dirty="0">
+                <a:solidFill>
+                  <a:srgbClr val="0F172A"/>
+                </a:solidFill>
+                <a:latin typeface="Google Sans Text" pitchFamily="34" charset="0"/>
+                <a:ea typeface="Google Sans Text" pitchFamily="34" charset="-122"/>
+                <a:cs typeface="Google Sans Text" pitchFamily="34" charset="-120"/>
+              </a:rPr>
+              <a:t>Prompt Injection Gate</a:t>
+            </a:r>
+            <a:endParaRPr lang="en-US" sz="820" dirty="0"/>
+          </a:p>
+        </p:txBody>
+      </p:sp>
+      <p:sp>
+        <p:nvSpPr>
+          <p:cNvPr id="28" name="Shape 26"/>
+          <p:cNvSpPr/>
+          <p:nvPr/>
+        </p:nvSpPr>
+        <p:spPr>
+          <a:xfrm>
+            <a:off x="2395728" y="2651760"/>
+            <a:ext cx="1463040" cy="694944"/>
+          </a:xfrm>
+          <a:prstGeom prst="roundRect">
+            <a:avLst>
+              <a:gd name="adj" fmla="val 7895"/>
+            </a:avLst>
+          </a:prstGeom>
+          <a:solidFill>
+            <a:srgbClr val="FFFFFF"/>
+          </a:solidFill>
+          <a:ln w="12700">
+            <a:solidFill>
+              <a:srgbClr val="1A73E8"/>
+            </a:solidFill>
+            <a:prstDash val="solid"/>
+          </a:ln>
+        </p:spPr>
+      </p:sp>
+      <p:sp>
+        <p:nvSpPr>
+          <p:cNvPr id="29" name="Text 27"/>
+          <p:cNvSpPr/>
+          <p:nvPr/>
+        </p:nvSpPr>
+        <p:spPr>
+          <a:xfrm>
+            <a:off x="2432304" y="2651760"/>
+            <a:ext cx="1389888" cy="694944"/>
+          </a:xfrm>
+          <a:prstGeom prst="rect">
+            <a:avLst/>
+          </a:prstGeom>
+          <a:noFill/>
+          <a:ln/>
+        </p:spPr>
+        <p:txBody>
+          <a:bodyPr wrap="square" rtlCol="0" anchor="ctr"/>
+          <a:lstStyle/>
+          <a:p>
+            <a:pPr algn="ctr" indent="0" marL="0">
+              <a:buNone/>
+            </a:pPr>
+            <a:r>
+              <a:rPr lang="en-US" sz="820" b="1" dirty="0">
+                <a:solidFill>
+                  <a:srgbClr val="0F172A"/>
+                </a:solidFill>
+                <a:latin typeface="Google Sans Text" pitchFamily="34" charset="0"/>
+                <a:ea typeface="Google Sans Text" pitchFamily="34" charset="-122"/>
+                <a:cs typeface="Google Sans Text" pitchFamily="34" charset="-120"/>
+              </a:rPr>
+              <a:t>Cloud Run Gen2</a:t>
+            </a:r>
+            <a:endParaRPr lang="en-US" sz="820" dirty="0"/>
+          </a:p>
+          <a:p>
+            <a:pPr algn="ctr" indent="0" marL="0">
+              <a:buNone/>
+            </a:pPr>
+            <a:r>
+              <a:rPr lang="en-US" sz="820" b="1" dirty="0">
+                <a:solidFill>
+                  <a:srgbClr val="0F172A"/>
+                </a:solidFill>
+                <a:latin typeface="Google Sans Text" pitchFamily="34" charset="0"/>
+                <a:ea typeface="Google Sans Text" pitchFamily="34" charset="-122"/>
+                <a:cs typeface="Google Sans Text" pitchFamily="34" charset="-120"/>
+              </a:rPr>
+              <a:t>gVisor 5-Hop Router</a:t>
+            </a:r>
+            <a:endParaRPr lang="en-US" sz="820" dirty="0"/>
+          </a:p>
+        </p:txBody>
+      </p:sp>
+      <p:sp>
+        <p:nvSpPr>
+          <p:cNvPr id="30" name="Shape 28"/>
+          <p:cNvSpPr/>
+          <p:nvPr/>
+        </p:nvSpPr>
+        <p:spPr>
+          <a:xfrm>
+            <a:off x="3968496" y="2651760"/>
+            <a:ext cx="1463040" cy="694944"/>
+          </a:xfrm>
+          <a:prstGeom prst="roundRect">
+            <a:avLst>
+              <a:gd name="adj" fmla="val 7895"/>
+            </a:avLst>
+          </a:prstGeom>
+          <a:solidFill>
+            <a:srgbClr val="FFFFFF"/>
+          </a:solidFill>
+          <a:ln w="12700">
+            <a:solidFill>
+              <a:srgbClr val="1A73E8"/>
+            </a:solidFill>
+            <a:prstDash val="solid"/>
+          </a:ln>
+        </p:spPr>
+      </p:sp>
+      <p:sp>
+        <p:nvSpPr>
+          <p:cNvPr id="31" name="Text 29"/>
+          <p:cNvSpPr/>
+          <p:nvPr/>
+        </p:nvSpPr>
+        <p:spPr>
+          <a:xfrm>
+            <a:off x="4005072" y="2651760"/>
+            <a:ext cx="1389888" cy="694944"/>
+          </a:xfrm>
+          <a:prstGeom prst="rect">
+            <a:avLst/>
+          </a:prstGeom>
+          <a:noFill/>
+          <a:ln/>
+        </p:spPr>
+        <p:txBody>
+          <a:bodyPr wrap="square" rtlCol="0" anchor="ctr"/>
+          <a:lstStyle/>
+          <a:p>
+            <a:pPr algn="ctr" indent="0" marL="0">
+              <a:buNone/>
+            </a:pPr>
+            <a:r>
+              <a:rPr lang="en-US" sz="820" b="1" dirty="0">
+                <a:solidFill>
+                  <a:srgbClr val="0F172A"/>
+                </a:solidFill>
+                <a:latin typeface="Google Sans Text" pitchFamily="34" charset="0"/>
+                <a:ea typeface="Google Sans Text" pitchFamily="34" charset="-122"/>
+                <a:cs typeface="Google Sans Text" pitchFamily="34" charset="-120"/>
+              </a:rPr>
+              <a:t>ARD Catalog PDP</a:t>
+            </a:r>
+            <a:endParaRPr lang="en-US" sz="820" dirty="0"/>
+          </a:p>
+          <a:p>
+            <a:pPr algn="ctr" indent="0" marL="0">
+              <a:buNone/>
+            </a:pPr>
+            <a:r>
+              <a:rPr lang="en-US" sz="820" b="1" dirty="0">
+                <a:solidFill>
+                  <a:srgbClr val="0F172A"/>
+                </a:solidFill>
+                <a:latin typeface="Google Sans Text" pitchFamily="34" charset="0"/>
+                <a:ea typeface="Google Sans Text" pitchFamily="34" charset="-122"/>
+                <a:cs typeface="Google Sans Text" pitchFamily="34" charset="-120"/>
+              </a:rPr>
+              <a:t>Tenant Tool Filter</a:t>
+            </a:r>
+            <a:endParaRPr lang="en-US" sz="820" dirty="0"/>
+          </a:p>
+        </p:txBody>
+      </p:sp>
+      <p:sp>
+        <p:nvSpPr>
+          <p:cNvPr id="32" name="Shape 30"/>
+          <p:cNvSpPr/>
+          <p:nvPr/>
+        </p:nvSpPr>
+        <p:spPr>
+          <a:xfrm>
+            <a:off x="2286000" y="2157984"/>
+            <a:ext cx="109728" cy="0"/>
+          </a:xfrm>
+          <a:prstGeom prst="line">
+            <a:avLst/>
+          </a:prstGeom>
+          <a:noFill/>
+          <a:ln w="19050">
+            <a:solidFill>
+              <a:srgbClr val="1A73E8"/>
+            </a:solidFill>
+            <a:prstDash val="solid"/>
+            <a:tailEnd type="arrow"/>
+          </a:ln>
+        </p:spPr>
+      </p:sp>
+      <p:sp>
+        <p:nvSpPr>
+          <p:cNvPr id="33" name="Shape 31"/>
+          <p:cNvSpPr/>
+          <p:nvPr/>
+        </p:nvSpPr>
+        <p:spPr>
+          <a:xfrm>
+            <a:off x="3858768" y="2157984"/>
+            <a:ext cx="109728" cy="0"/>
+          </a:xfrm>
+          <a:prstGeom prst="line">
+            <a:avLst/>
+          </a:prstGeom>
+          <a:noFill/>
+          <a:ln w="19050">
+            <a:solidFill>
+              <a:srgbClr val="1A73E8"/>
+            </a:solidFill>
+            <a:prstDash val="solid"/>
+            <a:tailEnd type="arrow"/>
+          </a:ln>
+        </p:spPr>
+      </p:sp>
+      <p:sp>
+        <p:nvSpPr>
+          <p:cNvPr id="34" name="Shape 32"/>
+          <p:cNvSpPr/>
+          <p:nvPr/>
+        </p:nvSpPr>
+        <p:spPr>
+          <a:xfrm>
+            <a:off x="3127248" y="2505456"/>
+            <a:ext cx="0" cy="146304"/>
+          </a:xfrm>
+          <a:prstGeom prst="line">
+            <a:avLst/>
+          </a:prstGeom>
+          <a:noFill/>
+          <a:ln w="19050">
+            <a:solidFill>
+              <a:srgbClr val="1A73E8"/>
+            </a:solidFill>
+            <a:prstDash val="solid"/>
+            <a:tailEnd type="arrow"/>
+          </a:ln>
+        </p:spPr>
+      </p:sp>
+      <p:sp>
+        <p:nvSpPr>
+          <p:cNvPr id="35" name="Shape 33"/>
+          <p:cNvSpPr/>
+          <p:nvPr/>
+        </p:nvSpPr>
+        <p:spPr>
+          <a:xfrm>
+            <a:off x="2286000" y="2999232"/>
+            <a:ext cx="109728" cy="0"/>
+          </a:xfrm>
+          <a:prstGeom prst="line">
+            <a:avLst/>
+          </a:prstGeom>
+          <a:noFill/>
+          <a:ln w="19050">
+            <a:solidFill>
+              <a:srgbClr val="1A73E8"/>
+            </a:solidFill>
+            <a:prstDash val="solid"/>
+            <a:tailEnd type="arrow"/>
+          </a:ln>
+        </p:spPr>
+      </p:sp>
+      <p:sp>
+        <p:nvSpPr>
+          <p:cNvPr id="36" name="Shape 34"/>
+          <p:cNvSpPr/>
+          <p:nvPr/>
+        </p:nvSpPr>
+        <p:spPr>
+          <a:xfrm>
+            <a:off x="3858768" y="2999232"/>
+            <a:ext cx="109728" cy="0"/>
+          </a:xfrm>
+          <a:prstGeom prst="line">
+            <a:avLst/>
+          </a:prstGeom>
+          <a:noFill/>
+          <a:ln w="19050">
+            <a:solidFill>
+              <a:srgbClr val="1A73E8"/>
+            </a:solidFill>
+            <a:prstDash val="solid"/>
+            <a:tailEnd type="arrow"/>
+          </a:ln>
+        </p:spPr>
+      </p:sp>
+      <p:sp>
+        <p:nvSpPr>
+          <p:cNvPr id="37" name="Shape 35"/>
+          <p:cNvSpPr/>
+          <p:nvPr/>
+        </p:nvSpPr>
+        <p:spPr>
+          <a:xfrm>
+            <a:off x="5742432" y="1444752"/>
+            <a:ext cx="2944368" cy="2057400"/>
+          </a:xfrm>
+          <a:prstGeom prst="roundRect">
+            <a:avLst>
+              <a:gd name="adj" fmla="val 3556"/>
+            </a:avLst>
+          </a:prstGeom>
+          <a:solidFill>
+            <a:srgbClr val="E6F4EA"/>
+          </a:solidFill>
+          <a:ln w="17780">
+            <a:solidFill>
+              <a:srgbClr val="1E8E3E"/>
+            </a:solidFill>
+            <a:prstDash val="solid"/>
+          </a:ln>
+        </p:spPr>
+      </p:sp>
+      <p:sp>
+        <p:nvSpPr>
+          <p:cNvPr id="38" name="Text 36"/>
+          <p:cNvSpPr/>
+          <p:nvPr/>
+        </p:nvSpPr>
+        <p:spPr>
+          <a:xfrm>
+            <a:off x="5870448" y="1499616"/>
+            <a:ext cx="2688336" cy="237744"/>
+          </a:xfrm>
+          <a:prstGeom prst="rect">
+            <a:avLst/>
+          </a:prstGeom>
+          <a:noFill/>
+          <a:ln/>
+        </p:spPr>
+        <p:txBody>
+          <a:bodyPr wrap="square" rtlCol="0" anchor="ctr"/>
+          <a:lstStyle/>
+          <a:p>
+            <a:pPr indent="0" marL="0">
+              <a:buNone/>
+            </a:pPr>
+            <a:r>
+              <a:rPr lang="en-US" sz="950" b="1" dirty="0">
+                <a:solidFill>
+                  <a:srgbClr val="1E8E3E"/>
+                </a:solidFill>
+                <a:latin typeface="Google Sans Display" pitchFamily="34" charset="0"/>
+                <a:ea typeface="Google Sans Display" pitchFamily="34" charset="-122"/>
+                <a:cs typeface="Google Sans Display" pitchFamily="34" charset="-120"/>
+              </a:rPr>
+              <a:t>2. Green Governance Hub</a:t>
+            </a:r>
+            <a:endParaRPr lang="en-US" sz="950" dirty="0"/>
+          </a:p>
+        </p:txBody>
+      </p:sp>
+      <p:sp>
+        <p:nvSpPr>
+          <p:cNvPr id="39" name="Shape 37"/>
+          <p:cNvSpPr/>
+          <p:nvPr/>
+        </p:nvSpPr>
+        <p:spPr>
+          <a:xfrm>
+            <a:off x="5888736" y="1810512"/>
+            <a:ext cx="2651760" cy="420624"/>
+          </a:xfrm>
+          <a:prstGeom prst="roundRect">
+            <a:avLst>
+              <a:gd name="adj" fmla="val 13043"/>
+            </a:avLst>
+          </a:prstGeom>
+          <a:solidFill>
+            <a:srgbClr val="FFFFFF"/>
+          </a:solidFill>
+          <a:ln w="12700">
+            <a:solidFill>
+              <a:srgbClr val="1E8E3E"/>
+            </a:solidFill>
+            <a:prstDash val="solid"/>
+          </a:ln>
+        </p:spPr>
+      </p:sp>
+      <p:sp>
+        <p:nvSpPr>
+          <p:cNvPr id="40" name="Text 38"/>
+          <p:cNvSpPr/>
+          <p:nvPr/>
+        </p:nvSpPr>
+        <p:spPr>
+          <a:xfrm>
+            <a:off x="5943600" y="1810512"/>
+            <a:ext cx="2542032" cy="420624"/>
+          </a:xfrm>
+          <a:prstGeom prst="rect">
+            <a:avLst/>
+          </a:prstGeom>
+          <a:noFill/>
+          <a:ln/>
+        </p:spPr>
+        <p:txBody>
+          <a:bodyPr wrap="square" rtlCol="0" anchor="ctr"/>
+          <a:lstStyle/>
+          <a:p>
+            <a:pPr algn="ctr" indent="0" marL="0">
+              <a:buNone/>
+            </a:pPr>
+            <a:r>
+              <a:rPr lang="en-US" sz="840" b="1" dirty="0">
+                <a:solidFill>
+                  <a:srgbClr val="0F172A"/>
+                </a:solidFill>
+                <a:latin typeface="Google Sans Text" pitchFamily="34" charset="0"/>
+                <a:ea typeface="Google Sans Text" pitchFamily="34" charset="-122"/>
+                <a:cs typeface="Google Sans Text" pitchFamily="34" charset="-120"/>
+              </a:rPr>
+              <a:t>Cloud KMS (ECDSA P-256 &amp; CMEK)</a:t>
+            </a:r>
+            <a:endParaRPr lang="en-US" sz="840" dirty="0"/>
+          </a:p>
+        </p:txBody>
+      </p:sp>
+      <p:sp>
+        <p:nvSpPr>
+          <p:cNvPr id="41" name="Shape 39"/>
+          <p:cNvSpPr/>
+          <p:nvPr/>
+        </p:nvSpPr>
+        <p:spPr>
+          <a:xfrm>
+            <a:off x="5888736" y="2340864"/>
+            <a:ext cx="2651760" cy="420624"/>
+          </a:xfrm>
+          <a:prstGeom prst="roundRect">
+            <a:avLst>
+              <a:gd name="adj" fmla="val 13043"/>
+            </a:avLst>
+          </a:prstGeom>
+          <a:solidFill>
+            <a:srgbClr val="FFFFFF"/>
+          </a:solidFill>
+          <a:ln w="12700">
+            <a:solidFill>
+              <a:srgbClr val="1E8E3E"/>
+            </a:solidFill>
+            <a:prstDash val="solid"/>
+          </a:ln>
+        </p:spPr>
+      </p:sp>
+      <p:sp>
+        <p:nvSpPr>
+          <p:cNvPr id="42" name="Text 40"/>
+          <p:cNvSpPr/>
+          <p:nvPr/>
+        </p:nvSpPr>
+        <p:spPr>
+          <a:xfrm>
+            <a:off x="5943600" y="2340864"/>
+            <a:ext cx="2542032" cy="420624"/>
+          </a:xfrm>
+          <a:prstGeom prst="rect">
+            <a:avLst/>
+          </a:prstGeom>
+          <a:noFill/>
+          <a:ln/>
+        </p:spPr>
+        <p:txBody>
+          <a:bodyPr wrap="square" rtlCol="0" anchor="ctr"/>
+          <a:lstStyle/>
+          <a:p>
+            <a:pPr algn="ctr" indent="0" marL="0">
+              <a:buNone/>
+            </a:pPr>
+            <a:r>
+              <a:rPr lang="en-US" sz="840" b="1" dirty="0">
+                <a:solidFill>
+                  <a:srgbClr val="0F172A"/>
+                </a:solidFill>
+                <a:latin typeface="Google Sans Text" pitchFamily="34" charset="0"/>
+                <a:ea typeface="Google Sans Text" pitchFamily="34" charset="-122"/>
+                <a:cs typeface="Google Sans Text" pitchFamily="34" charset="-120"/>
+              </a:rPr>
+              <a:t>Central IAM &amp; Principal Access Boundary</a:t>
+            </a:r>
+            <a:endParaRPr lang="en-US" sz="840" dirty="0"/>
+          </a:p>
+        </p:txBody>
+      </p:sp>
+      <p:sp>
+        <p:nvSpPr>
+          <p:cNvPr id="43" name="Shape 41"/>
+          <p:cNvSpPr/>
+          <p:nvPr/>
+        </p:nvSpPr>
+        <p:spPr>
+          <a:xfrm>
+            <a:off x="5888736" y="2871216"/>
+            <a:ext cx="2651760" cy="420624"/>
+          </a:xfrm>
+          <a:prstGeom prst="roundRect">
+            <a:avLst>
+              <a:gd name="adj" fmla="val 13043"/>
+            </a:avLst>
+          </a:prstGeom>
+          <a:solidFill>
+            <a:srgbClr val="FFFFFF"/>
+          </a:solidFill>
+          <a:ln w="12700">
+            <a:solidFill>
+              <a:srgbClr val="1E8E3E"/>
+            </a:solidFill>
+            <a:prstDash val="solid"/>
+          </a:ln>
+        </p:spPr>
+      </p:sp>
+      <p:sp>
+        <p:nvSpPr>
+          <p:cNvPr id="44" name="Text 42"/>
+          <p:cNvSpPr/>
+          <p:nvPr/>
+        </p:nvSpPr>
+        <p:spPr>
+          <a:xfrm>
+            <a:off x="5943600" y="2871216"/>
+            <a:ext cx="2542032" cy="420624"/>
+          </a:xfrm>
+          <a:prstGeom prst="rect">
+            <a:avLst/>
+          </a:prstGeom>
+          <a:noFill/>
+          <a:ln/>
+        </p:spPr>
+        <p:txBody>
+          <a:bodyPr wrap="square" rtlCol="0" anchor="ctr"/>
+          <a:lstStyle/>
+          <a:p>
+            <a:pPr algn="ctr" indent="0" marL="0">
+              <a:buNone/>
+            </a:pPr>
+            <a:r>
+              <a:rPr lang="en-US" sz="840" b="1" dirty="0">
+                <a:solidFill>
+                  <a:srgbClr val="0F172A"/>
+                </a:solidFill>
+                <a:latin typeface="Google Sans Text" pitchFamily="34" charset="0"/>
+                <a:ea typeface="Google Sans Text" pitchFamily="34" charset="-122"/>
+                <a:cs typeface="Google Sans Text" pitchFamily="34" charset="-120"/>
+              </a:rPr>
+              <a:t>Cloud Logging &amp; BigQuery OTel FinOps</a:t>
+            </a:r>
+            <a:endParaRPr lang="en-US" sz="840" dirty="0"/>
+          </a:p>
+        </p:txBody>
+      </p:sp>
+      <p:sp>
+        <p:nvSpPr>
+          <p:cNvPr id="45" name="Shape 43"/>
+          <p:cNvSpPr/>
+          <p:nvPr/>
+        </p:nvSpPr>
+        <p:spPr>
+          <a:xfrm>
+            <a:off x="5577840" y="2468880"/>
+            <a:ext cx="164592" cy="0"/>
+          </a:xfrm>
+          <a:prstGeom prst="line">
+            <a:avLst/>
+          </a:prstGeom>
+          <a:noFill/>
+          <a:ln w="22225">
+            <a:solidFill>
+              <a:srgbClr val="1E8E3E"/>
+            </a:solidFill>
+            <a:prstDash val="solid"/>
+            <a:tailEnd type="arrow"/>
+          </a:ln>
+        </p:spPr>
+      </p:sp>
+      <p:sp>
+        <p:nvSpPr>
+          <p:cNvPr id="46" name="Shape 44"/>
+          <p:cNvSpPr/>
+          <p:nvPr/>
+        </p:nvSpPr>
+        <p:spPr>
+          <a:xfrm>
+            <a:off x="2560320" y="3502152"/>
+            <a:ext cx="0" cy="411480"/>
+          </a:xfrm>
+          <a:prstGeom prst="line">
+            <a:avLst/>
+          </a:prstGeom>
+          <a:noFill/>
+          <a:ln w="25400">
+            <a:solidFill>
+              <a:srgbClr val="B06000"/>
+            </a:solidFill>
+            <a:prstDash val="solid"/>
+            <a:tailEnd type="arrow"/>
+          </a:ln>
+        </p:spPr>
+      </p:sp>
+      <p:sp>
+        <p:nvSpPr>
+          <p:cNvPr id="47" name="Shape 45"/>
+          <p:cNvSpPr/>
+          <p:nvPr/>
+        </p:nvSpPr>
+        <p:spPr>
+          <a:xfrm>
+            <a:off x="6583680" y="3502152"/>
+            <a:ext cx="0" cy="411480"/>
+          </a:xfrm>
+          <a:prstGeom prst="line">
+            <a:avLst/>
+          </a:prstGeom>
+          <a:noFill/>
+          <a:ln w="25400">
+            <a:solidFill>
+              <a:srgbClr val="D93025"/>
+            </a:solidFill>
+            <a:prstDash val="solid"/>
+            <a:tailEnd type="arrow"/>
+          </a:ln>
+        </p:spPr>
+      </p:sp>
+      <p:sp>
+        <p:nvSpPr>
+          <p:cNvPr id="48" name="Shape 46"/>
+          <p:cNvSpPr/>
+          <p:nvPr/>
+        </p:nvSpPr>
+        <p:spPr>
+          <a:xfrm>
+            <a:off x="685800" y="3913632"/>
+            <a:ext cx="3886200" cy="2304288"/>
+          </a:xfrm>
+          <a:prstGeom prst="roundRect">
+            <a:avLst>
+              <a:gd name="adj" fmla="val 3175"/>
+            </a:avLst>
+          </a:prstGeom>
+          <a:solidFill>
+            <a:srgbClr val="FEF7E0"/>
+          </a:solidFill>
+          <a:ln w="17780">
+            <a:solidFill>
+              <a:srgbClr val="B06000"/>
+            </a:solidFill>
+            <a:prstDash val="solid"/>
+          </a:ln>
+        </p:spPr>
+      </p:sp>
+      <p:sp>
+        <p:nvSpPr>
+          <p:cNvPr id="49" name="Text 47"/>
+          <p:cNvSpPr/>
+          <p:nvPr/>
+        </p:nvSpPr>
+        <p:spPr>
+          <a:xfrm>
+            <a:off x="822960" y="3968496"/>
+            <a:ext cx="3611880" cy="237744"/>
+          </a:xfrm>
+          <a:prstGeom prst="rect">
+            <a:avLst/>
+          </a:prstGeom>
+          <a:noFill/>
+          <a:ln/>
+        </p:spPr>
+        <p:txBody>
+          <a:bodyPr wrap="square" rtlCol="0" anchor="ctr"/>
+          <a:lstStyle/>
+          <a:p>
+            <a:pPr indent="0" marL="0">
+              <a:buNone/>
+            </a:pPr>
+            <a:r>
+              <a:rPr lang="en-US" sz="900" b="1" dirty="0">
+                <a:solidFill>
+                  <a:srgbClr val="B06000"/>
+                </a:solidFill>
+                <a:latin typeface="Google Sans Display" pitchFamily="34" charset="0"/>
+                <a:ea typeface="Google Sans Display" pitchFamily="34" charset="-122"/>
+                <a:cs typeface="Google Sans Display" pitchFamily="34" charset="-120"/>
+              </a:rPr>
+              <a:t>3. Yellow Spoke • Pattern A Shared Pool (950 Tenants)</a:t>
+            </a:r>
+            <a:endParaRPr lang="en-US" sz="900" dirty="0"/>
+          </a:p>
+        </p:txBody>
+      </p:sp>
+      <p:sp>
+        <p:nvSpPr>
+          <p:cNvPr id="50" name="Shape 48"/>
+          <p:cNvSpPr/>
+          <p:nvPr/>
+        </p:nvSpPr>
+        <p:spPr>
+          <a:xfrm>
+            <a:off x="822960" y="4279392"/>
+            <a:ext cx="1737360" cy="804672"/>
+          </a:xfrm>
+          <a:prstGeom prst="roundRect">
+            <a:avLst>
+              <a:gd name="adj" fmla="val 6818"/>
+            </a:avLst>
+          </a:prstGeom>
+          <a:solidFill>
+            <a:srgbClr val="FFFFFF"/>
+          </a:solidFill>
+          <a:ln w="12700">
+            <a:solidFill>
+              <a:srgbClr val="B06000"/>
+            </a:solidFill>
+            <a:prstDash val="solid"/>
+          </a:ln>
+        </p:spPr>
+      </p:sp>
+      <p:sp>
+        <p:nvSpPr>
+          <p:cNvPr id="51" name="Text 49"/>
+          <p:cNvSpPr/>
+          <p:nvPr/>
+        </p:nvSpPr>
+        <p:spPr>
+          <a:xfrm>
+            <a:off x="877824" y="4279392"/>
+            <a:ext cx="1627632" cy="804672"/>
+          </a:xfrm>
+          <a:prstGeom prst="rect">
+            <a:avLst/>
+          </a:prstGeom>
+          <a:noFill/>
+          <a:ln/>
+        </p:spPr>
+        <p:txBody>
+          <a:bodyPr wrap="square" rtlCol="0" anchor="ctr"/>
+          <a:lstStyle/>
+          <a:p>
+            <a:pPr algn="ctr" indent="0" marL="0">
+              <a:buNone/>
+            </a:pPr>
+            <a:r>
+              <a:rPr lang="en-US" sz="830" b="1" dirty="0">
+                <a:solidFill>
+                  <a:srgbClr val="0F172A"/>
+                </a:solidFill>
+                <a:latin typeface="Google Sans Text" pitchFamily="34" charset="0"/>
+                <a:ea typeface="Google Sans Text" pitchFamily="34" charset="-122"/>
+                <a:cs typeface="Google Sans Text" pitchFamily="34" charset="-120"/>
+              </a:rPr>
+              <a:t>Vertex AI Agent Engine</a:t>
+            </a:r>
+            <a:endParaRPr lang="en-US" sz="830" dirty="0"/>
+          </a:p>
+          <a:p>
+            <a:pPr algn="ctr" indent="0" marL="0">
+              <a:buNone/>
+            </a:pPr>
+            <a:r>
+              <a:rPr lang="en-US" sz="830" b="1" dirty="0">
+                <a:solidFill>
+                  <a:srgbClr val="0F172A"/>
+                </a:solidFill>
+                <a:latin typeface="Google Sans Text" pitchFamily="34" charset="0"/>
+                <a:ea typeface="Google Sans Text" pitchFamily="34" charset="-122"/>
+                <a:cs typeface="Google Sans Text" pitchFamily="34" charset="-120"/>
+              </a:rPr>
+              <a:t>gVisor + 32k Prefix Cache</a:t>
+            </a:r>
+            <a:endParaRPr lang="en-US" sz="830" dirty="0"/>
+          </a:p>
+        </p:txBody>
+      </p:sp>
+      <p:sp>
+        <p:nvSpPr>
+          <p:cNvPr id="52" name="Shape 50"/>
+          <p:cNvSpPr/>
+          <p:nvPr/>
+        </p:nvSpPr>
+        <p:spPr>
+          <a:xfrm>
+            <a:off x="2697480" y="4279392"/>
+            <a:ext cx="1737360" cy="804672"/>
+          </a:xfrm>
+          <a:prstGeom prst="roundRect">
+            <a:avLst>
+              <a:gd name="adj" fmla="val 6818"/>
+            </a:avLst>
+          </a:prstGeom>
+          <a:solidFill>
+            <a:srgbClr val="FFFFFF"/>
+          </a:solidFill>
+          <a:ln w="12700">
+            <a:solidFill>
+              <a:srgbClr val="B06000"/>
+            </a:solidFill>
+            <a:prstDash val="solid"/>
+          </a:ln>
+        </p:spPr>
+      </p:sp>
+      <p:sp>
+        <p:nvSpPr>
+          <p:cNvPr id="53" name="Text 51"/>
+          <p:cNvSpPr/>
+          <p:nvPr/>
+        </p:nvSpPr>
+        <p:spPr>
+          <a:xfrm>
+            <a:off x="2752344" y="4279392"/>
+            <a:ext cx="1627632" cy="804672"/>
+          </a:xfrm>
+          <a:prstGeom prst="rect">
+            <a:avLst/>
+          </a:prstGeom>
+          <a:noFill/>
+          <a:ln/>
+        </p:spPr>
+        <p:txBody>
+          <a:bodyPr wrap="square" rtlCol="0" anchor="ctr"/>
+          <a:lstStyle/>
+          <a:p>
+            <a:pPr algn="ctr" indent="0" marL="0">
+              <a:buNone/>
+            </a:pPr>
+            <a:r>
+              <a:rPr lang="en-US" sz="830" b="1" dirty="0">
+                <a:solidFill>
+                  <a:srgbClr val="0F172A"/>
+                </a:solidFill>
+                <a:latin typeface="Google Sans Text" pitchFamily="34" charset="0"/>
+                <a:ea typeface="Google Sans Text" pitchFamily="34" charset="-122"/>
+                <a:cs typeface="Google Sans Text" pitchFamily="34" charset="-120"/>
+              </a:rPr>
+              <a:t>Model Armor DLP</a:t>
+            </a:r>
+            <a:endParaRPr lang="en-US" sz="830" dirty="0"/>
+          </a:p>
+          <a:p>
+            <a:pPr algn="ctr" indent="0" marL="0">
+              <a:buNone/>
+            </a:pPr>
+            <a:r>
+              <a:rPr lang="en-US" sz="830" b="1" dirty="0">
+                <a:solidFill>
+                  <a:srgbClr val="0F172A"/>
+                </a:solidFill>
+                <a:latin typeface="Google Sans Text" pitchFamily="34" charset="0"/>
+                <a:ea typeface="Google Sans Text" pitchFamily="34" charset="-122"/>
+                <a:cs typeface="Google Sans Text" pitchFamily="34" charset="-120"/>
+              </a:rPr>
+              <a:t>Inline PII/PHI Redaction</a:t>
+            </a:r>
+            <a:endParaRPr lang="en-US" sz="830" dirty="0"/>
+          </a:p>
+        </p:txBody>
+      </p:sp>
+      <p:sp>
+        <p:nvSpPr>
+          <p:cNvPr id="54" name="Shape 52"/>
+          <p:cNvSpPr/>
+          <p:nvPr/>
+        </p:nvSpPr>
+        <p:spPr>
+          <a:xfrm>
+            <a:off x="822960" y="5230368"/>
+            <a:ext cx="1737360" cy="804672"/>
+          </a:xfrm>
+          <a:prstGeom prst="roundRect">
+            <a:avLst>
+              <a:gd name="adj" fmla="val 6818"/>
+            </a:avLst>
+          </a:prstGeom>
+          <a:solidFill>
+            <a:srgbClr val="FFFFFF"/>
+          </a:solidFill>
+          <a:ln w="12700">
+            <a:solidFill>
+              <a:srgbClr val="B06000"/>
+            </a:solidFill>
+            <a:prstDash val="solid"/>
+          </a:ln>
+        </p:spPr>
+      </p:sp>
+      <p:sp>
+        <p:nvSpPr>
+          <p:cNvPr id="55" name="Text 53"/>
+          <p:cNvSpPr/>
+          <p:nvPr/>
+        </p:nvSpPr>
+        <p:spPr>
+          <a:xfrm>
+            <a:off x="877824" y="5230368"/>
+            <a:ext cx="1627632" cy="804672"/>
+          </a:xfrm>
+          <a:prstGeom prst="rect">
+            <a:avLst/>
+          </a:prstGeom>
+          <a:noFill/>
+          <a:ln/>
+        </p:spPr>
+        <p:txBody>
+          <a:bodyPr wrap="square" rtlCol="0" anchor="ctr"/>
+          <a:lstStyle/>
+          <a:p>
+            <a:pPr algn="ctr" indent="0" marL="0">
+              <a:buNone/>
+            </a:pPr>
+            <a:r>
+              <a:rPr lang="en-US" sz="830" b="1" dirty="0">
+                <a:solidFill>
+                  <a:srgbClr val="0F172A"/>
+                </a:solidFill>
+                <a:latin typeface="Google Sans Text" pitchFamily="34" charset="0"/>
+                <a:ea typeface="Google Sans Text" pitchFamily="34" charset="-122"/>
+                <a:cs typeface="Google Sans Text" pitchFamily="34" charset="-120"/>
+              </a:rPr>
+              <a:t>Scoped MCP Hub</a:t>
+            </a:r>
+            <a:endParaRPr lang="en-US" sz="830" dirty="0"/>
+          </a:p>
+          <a:p>
+            <a:pPr algn="ctr" indent="0" marL="0">
+              <a:buNone/>
+            </a:pPr>
+            <a:r>
+              <a:rPr lang="en-US" sz="830" b="1" dirty="0">
+                <a:solidFill>
+                  <a:srgbClr val="0F172A"/>
+                </a:solidFill>
+                <a:latin typeface="Google Sans Text" pitchFamily="34" charset="0"/>
+                <a:ea typeface="Google Sans Text" pitchFamily="34" charset="-122"/>
+                <a:cs typeface="Google Sans Text" pitchFamily="34" charset="-120"/>
+              </a:rPr>
+              <a:t>2LO + 3LO OAuth Vaults</a:t>
+            </a:r>
+            <a:endParaRPr lang="en-US" sz="830" dirty="0"/>
+          </a:p>
+        </p:txBody>
+      </p:sp>
+      <p:sp>
+        <p:nvSpPr>
+          <p:cNvPr id="56" name="Shape 54"/>
+          <p:cNvSpPr/>
+          <p:nvPr/>
+        </p:nvSpPr>
+        <p:spPr>
+          <a:xfrm>
+            <a:off x="2697480" y="5230368"/>
+            <a:ext cx="1737360" cy="804672"/>
+          </a:xfrm>
+          <a:prstGeom prst="roundRect">
+            <a:avLst>
+              <a:gd name="adj" fmla="val 6818"/>
+            </a:avLst>
+          </a:prstGeom>
+          <a:solidFill>
+            <a:srgbClr val="FFFFFF"/>
+          </a:solidFill>
+          <a:ln w="12700">
+            <a:solidFill>
+              <a:srgbClr val="B06000"/>
+            </a:solidFill>
+            <a:prstDash val="solid"/>
+          </a:ln>
+        </p:spPr>
+      </p:sp>
+      <p:sp>
+        <p:nvSpPr>
+          <p:cNvPr id="57" name="Text 55"/>
+          <p:cNvSpPr/>
+          <p:nvPr/>
+        </p:nvSpPr>
+        <p:spPr>
+          <a:xfrm>
+            <a:off x="2752344" y="5230368"/>
+            <a:ext cx="1627632" cy="804672"/>
+          </a:xfrm>
+          <a:prstGeom prst="rect">
+            <a:avLst/>
+          </a:prstGeom>
+          <a:noFill/>
+          <a:ln/>
+        </p:spPr>
+        <p:txBody>
+          <a:bodyPr wrap="square" rtlCol="0" anchor="ctr"/>
+          <a:lstStyle/>
+          <a:p>
+            <a:pPr algn="ctr" indent="0" marL="0">
+              <a:buNone/>
+            </a:pPr>
+            <a:r>
+              <a:rPr lang="en-US" sz="830" b="1" dirty="0">
+                <a:solidFill>
+                  <a:srgbClr val="0F172A"/>
+                </a:solidFill>
+                <a:latin typeface="Google Sans Text" pitchFamily="34" charset="0"/>
+                <a:ea typeface="Google Sans Text" pitchFamily="34" charset="-122"/>
+                <a:cs typeface="Google Sans Text" pitchFamily="34" charset="-120"/>
+              </a:rPr>
+              <a:t>AlloyDB &amp; BQ RLS</a:t>
+            </a:r>
+            <a:endParaRPr lang="en-US" sz="830" dirty="0"/>
+          </a:p>
+          <a:p>
+            <a:pPr algn="ctr" indent="0" marL="0">
+              <a:buNone/>
+            </a:pPr>
+            <a:r>
+              <a:rPr lang="en-US" sz="830" b="1" dirty="0">
+                <a:solidFill>
+                  <a:srgbClr val="0F172A"/>
+                </a:solidFill>
+                <a:latin typeface="Google Sans Text" pitchFamily="34" charset="0"/>
+                <a:ea typeface="Google Sans Text" pitchFamily="34" charset="-122"/>
+                <a:cs typeface="Google Sans Text" pitchFamily="34" charset="-120"/>
+              </a:rPr>
+              <a:t>FORCE ROW SECURITY</a:t>
+            </a:r>
+            <a:endParaRPr lang="en-US" sz="830" dirty="0"/>
+          </a:p>
+        </p:txBody>
+      </p:sp>
+      <p:sp>
+        <p:nvSpPr>
+          <p:cNvPr id="58" name="Shape 56"/>
+          <p:cNvSpPr/>
+          <p:nvPr/>
+        </p:nvSpPr>
+        <p:spPr>
+          <a:xfrm>
+            <a:off x="2560320" y="4681728"/>
+            <a:ext cx="137160" cy="0"/>
+          </a:xfrm>
+          <a:prstGeom prst="line">
+            <a:avLst/>
+          </a:prstGeom>
+          <a:noFill/>
+          <a:ln w="19050">
+            <a:solidFill>
+              <a:srgbClr val="B06000"/>
+            </a:solidFill>
+            <a:prstDash val="solid"/>
+            <a:tailEnd type="arrow"/>
+          </a:ln>
+        </p:spPr>
+      </p:sp>
+      <p:sp>
+        <p:nvSpPr>
+          <p:cNvPr id="59" name="Shape 57"/>
+          <p:cNvSpPr/>
+          <p:nvPr/>
+        </p:nvSpPr>
+        <p:spPr>
+          <a:xfrm>
+            <a:off x="1691640" y="5084064"/>
+            <a:ext cx="0" cy="146304"/>
+          </a:xfrm>
+          <a:prstGeom prst="line">
+            <a:avLst/>
+          </a:prstGeom>
+          <a:noFill/>
+          <a:ln w="19050">
+            <a:solidFill>
+              <a:srgbClr val="B06000"/>
+            </a:solidFill>
+            <a:prstDash val="solid"/>
+            <a:tailEnd type="arrow"/>
+          </a:ln>
+        </p:spPr>
+      </p:sp>
+      <p:sp>
+        <p:nvSpPr>
+          <p:cNvPr id="60" name="Shape 58"/>
+          <p:cNvSpPr/>
+          <p:nvPr/>
+        </p:nvSpPr>
+        <p:spPr>
+          <a:xfrm>
+            <a:off x="2560320" y="5632704"/>
+            <a:ext cx="137160" cy="0"/>
+          </a:xfrm>
+          <a:prstGeom prst="line">
+            <a:avLst/>
+          </a:prstGeom>
+          <a:noFill/>
+          <a:ln w="19050">
+            <a:solidFill>
+              <a:srgbClr val="B06000"/>
+            </a:solidFill>
+            <a:prstDash val="solid"/>
+            <a:tailEnd type="arrow"/>
+          </a:ln>
+        </p:spPr>
+      </p:sp>
+      <p:sp>
+        <p:nvSpPr>
+          <p:cNvPr id="61" name="Shape 59"/>
+          <p:cNvSpPr/>
+          <p:nvPr/>
+        </p:nvSpPr>
+        <p:spPr>
+          <a:xfrm>
+            <a:off x="4800600" y="3913632"/>
+            <a:ext cx="3886200" cy="2304288"/>
+          </a:xfrm>
+          <a:prstGeom prst="roundRect">
+            <a:avLst>
+              <a:gd name="adj" fmla="val 3175"/>
+            </a:avLst>
+          </a:prstGeom>
+          <a:solidFill>
+            <a:srgbClr val="FCE8E6"/>
+          </a:solidFill>
+          <a:ln w="17780">
+            <a:solidFill>
+              <a:srgbClr val="D93025"/>
+            </a:solidFill>
+            <a:prstDash val="solid"/>
+          </a:ln>
+        </p:spPr>
+      </p:sp>
+      <p:sp>
+        <p:nvSpPr>
+          <p:cNvPr id="62" name="Text 60"/>
+          <p:cNvSpPr/>
+          <p:nvPr/>
+        </p:nvSpPr>
+        <p:spPr>
+          <a:xfrm>
+            <a:off x="4937760" y="3968496"/>
+            <a:ext cx="3611880" cy="237744"/>
+          </a:xfrm>
+          <a:prstGeom prst="rect">
+            <a:avLst/>
+          </a:prstGeom>
+          <a:noFill/>
+          <a:ln/>
+        </p:spPr>
+        <p:txBody>
+          <a:bodyPr wrap="square" rtlCol="0" anchor="ctr"/>
+          <a:lstStyle/>
+          <a:p>
+            <a:pPr indent="0" marL="0">
+              <a:buNone/>
+            </a:pPr>
+            <a:r>
+              <a:rPr lang="en-US" sz="900" b="1" dirty="0">
+                <a:solidFill>
+                  <a:srgbClr val="D93025"/>
+                </a:solidFill>
+                <a:latin typeface="Google Sans Display" pitchFamily="34" charset="0"/>
+                <a:ea typeface="Google Sans Display" pitchFamily="34" charset="-122"/>
+                <a:cs typeface="Google Sans Display" pitchFamily="34" charset="-120"/>
+              </a:rPr>
+              <a:t>4. Red Spoke • Pattern B/C Sovereign Silo (50 Banks)</a:t>
+            </a:r>
+            <a:endParaRPr lang="en-US" sz="900" dirty="0"/>
+          </a:p>
+        </p:txBody>
+      </p:sp>
+      <p:sp>
+        <p:nvSpPr>
+          <p:cNvPr id="63" name="Shape 61"/>
+          <p:cNvSpPr/>
+          <p:nvPr/>
+        </p:nvSpPr>
+        <p:spPr>
+          <a:xfrm>
+            <a:off x="4937760" y="4279392"/>
+            <a:ext cx="1737360" cy="804672"/>
+          </a:xfrm>
+          <a:prstGeom prst="roundRect">
+            <a:avLst>
+              <a:gd name="adj" fmla="val 6818"/>
+            </a:avLst>
+          </a:prstGeom>
+          <a:solidFill>
+            <a:srgbClr val="FFFFFF"/>
+          </a:solidFill>
+          <a:ln w="12700">
+            <a:solidFill>
+              <a:srgbClr val="D93025"/>
+            </a:solidFill>
+            <a:prstDash val="solid"/>
+          </a:ln>
+        </p:spPr>
+      </p:sp>
+      <p:sp>
+        <p:nvSpPr>
+          <p:cNvPr id="64" name="Text 62"/>
+          <p:cNvSpPr/>
+          <p:nvPr/>
+        </p:nvSpPr>
+        <p:spPr>
+          <a:xfrm>
+            <a:off x="4992624" y="4279392"/>
+            <a:ext cx="1627632" cy="804672"/>
+          </a:xfrm>
+          <a:prstGeom prst="rect">
+            <a:avLst/>
+          </a:prstGeom>
+          <a:noFill/>
+          <a:ln/>
+        </p:spPr>
+        <p:txBody>
+          <a:bodyPr wrap="square" rtlCol="0" anchor="ctr"/>
+          <a:lstStyle/>
+          <a:p>
+            <a:pPr algn="ctr" indent="0" marL="0">
+              <a:buNone/>
+            </a:pPr>
+            <a:r>
+              <a:rPr lang="en-US" sz="830" b="1" dirty="0">
+                <a:solidFill>
+                  <a:srgbClr val="0F172A"/>
+                </a:solidFill>
+                <a:latin typeface="Google Sans Text" pitchFamily="34" charset="0"/>
+                <a:ea typeface="Google Sans Text" pitchFamily="34" charset="-122"/>
+                <a:cs typeface="Google Sans Text" pitchFamily="34" charset="-120"/>
+              </a:rPr>
+              <a:t>Dedicated VPC-SC</a:t>
+            </a:r>
+            <a:endParaRPr lang="en-US" sz="830" dirty="0"/>
+          </a:p>
+          <a:p>
+            <a:pPr algn="ctr" indent="0" marL="0">
+              <a:buNone/>
+            </a:pPr>
+            <a:r>
+              <a:rPr lang="en-US" sz="830" b="1" dirty="0">
+                <a:solidFill>
+                  <a:srgbClr val="0F172A"/>
+                </a:solidFill>
+                <a:latin typeface="Google Sans Text" pitchFamily="34" charset="0"/>
+                <a:ea typeface="Google Sans Text" pitchFamily="34" charset="-122"/>
+                <a:cs typeface="Google Sans Text" pitchFamily="34" charset="-120"/>
+              </a:rPr>
+              <a:t>Zero Egress Perimeter</a:t>
+            </a:r>
+            <a:endParaRPr lang="en-US" sz="830" dirty="0"/>
+          </a:p>
+        </p:txBody>
+      </p:sp>
+      <p:sp>
+        <p:nvSpPr>
+          <p:cNvPr id="65" name="Shape 63"/>
+          <p:cNvSpPr/>
+          <p:nvPr/>
+        </p:nvSpPr>
+        <p:spPr>
+          <a:xfrm>
+            <a:off x="6812280" y="4279392"/>
+            <a:ext cx="1737360" cy="804672"/>
+          </a:xfrm>
+          <a:prstGeom prst="roundRect">
+            <a:avLst>
+              <a:gd name="adj" fmla="val 6818"/>
+            </a:avLst>
+          </a:prstGeom>
+          <a:solidFill>
+            <a:srgbClr val="FFFFFF"/>
+          </a:solidFill>
+          <a:ln w="12700">
+            <a:solidFill>
+              <a:srgbClr val="D93025"/>
+            </a:solidFill>
+            <a:prstDash val="solid"/>
+          </a:ln>
+        </p:spPr>
+      </p:sp>
+      <p:sp>
+        <p:nvSpPr>
+          <p:cNvPr id="66" name="Text 64"/>
+          <p:cNvSpPr/>
+          <p:nvPr/>
+        </p:nvSpPr>
+        <p:spPr>
+          <a:xfrm>
+            <a:off x="6867144" y="4279392"/>
+            <a:ext cx="1627632" cy="804672"/>
+          </a:xfrm>
+          <a:prstGeom prst="rect">
+            <a:avLst/>
+          </a:prstGeom>
+          <a:noFill/>
+          <a:ln/>
+        </p:spPr>
+        <p:txBody>
+          <a:bodyPr wrap="square" rtlCol="0" anchor="ctr"/>
+          <a:lstStyle/>
+          <a:p>
+            <a:pPr algn="ctr" indent="0" marL="0">
+              <a:buNone/>
+            </a:pPr>
+            <a:r>
+              <a:rPr lang="en-US" sz="830" b="1" dirty="0">
+                <a:solidFill>
+                  <a:srgbClr val="0F172A"/>
+                </a:solidFill>
+                <a:latin typeface="Google Sans Text" pitchFamily="34" charset="0"/>
+                <a:ea typeface="Google Sans Text" pitchFamily="34" charset="-122"/>
+                <a:cs typeface="Google Sans Text" pitchFamily="34" charset="-120"/>
+              </a:rPr>
+              <a:t>Vertex PT / Private GKE</a:t>
+            </a:r>
+            <a:endParaRPr lang="en-US" sz="830" dirty="0"/>
+          </a:p>
+          <a:p>
+            <a:pPr algn="ctr" indent="0" marL="0">
+              <a:buNone/>
+            </a:pPr>
+            <a:r>
+              <a:rPr lang="en-US" sz="830" b="1" dirty="0">
+                <a:solidFill>
+                  <a:srgbClr val="0F172A"/>
+                </a:solidFill>
+                <a:latin typeface="Google Sans Text" pitchFamily="34" charset="0"/>
+                <a:ea typeface="Google Sans Text" pitchFamily="34" charset="-122"/>
+                <a:cs typeface="Google Sans Text" pitchFamily="34" charset="-120"/>
+              </a:rPr>
+              <a:t>Dedicated Gemma 3 27B</a:t>
+            </a:r>
+            <a:endParaRPr lang="en-US" sz="830" dirty="0"/>
+          </a:p>
+        </p:txBody>
+      </p:sp>
+      <p:sp>
+        <p:nvSpPr>
+          <p:cNvPr id="67" name="Shape 65"/>
+          <p:cNvSpPr/>
+          <p:nvPr/>
+        </p:nvSpPr>
+        <p:spPr>
+          <a:xfrm>
+            <a:off x="4937760" y="5230368"/>
+            <a:ext cx="1737360" cy="804672"/>
+          </a:xfrm>
+          <a:prstGeom prst="roundRect">
+            <a:avLst>
+              <a:gd name="adj" fmla="val 6818"/>
+            </a:avLst>
+          </a:prstGeom>
+          <a:solidFill>
+            <a:srgbClr val="FFFFFF"/>
+          </a:solidFill>
+          <a:ln w="12700">
+            <a:solidFill>
+              <a:srgbClr val="D93025"/>
+            </a:solidFill>
+            <a:prstDash val="solid"/>
+          </a:ln>
+        </p:spPr>
+      </p:sp>
+      <p:sp>
+        <p:nvSpPr>
+          <p:cNvPr id="68" name="Text 66"/>
+          <p:cNvSpPr/>
+          <p:nvPr/>
+        </p:nvSpPr>
+        <p:spPr>
+          <a:xfrm>
+            <a:off x="4992624" y="5230368"/>
+            <a:ext cx="1627632" cy="804672"/>
+          </a:xfrm>
+          <a:prstGeom prst="rect">
+            <a:avLst/>
+          </a:prstGeom>
+          <a:noFill/>
+          <a:ln/>
+        </p:spPr>
+        <p:txBody>
+          <a:bodyPr wrap="square" rtlCol="0" anchor="ctr"/>
+          <a:lstStyle/>
+          <a:p>
+            <a:pPr algn="ctr" indent="0" marL="0">
+              <a:buNone/>
+            </a:pPr>
+            <a:r>
+              <a:rPr lang="en-US" sz="830" b="1" dirty="0">
+                <a:solidFill>
+                  <a:srgbClr val="0F172A"/>
+                </a:solidFill>
+                <a:latin typeface="Google Sans Text" pitchFamily="34" charset="0"/>
+                <a:ea typeface="Google Sans Text" pitchFamily="34" charset="-122"/>
+                <a:cs typeface="Google Sans Text" pitchFamily="34" charset="-120"/>
+              </a:rPr>
+              <a:t>Customer KMS Key</a:t>
+            </a:r>
+            <a:endParaRPr lang="en-US" sz="830" dirty="0"/>
+          </a:p>
+          <a:p>
+            <a:pPr algn="ctr" indent="0" marL="0">
+              <a:buNone/>
+            </a:pPr>
+            <a:r>
+              <a:rPr lang="en-US" sz="830" b="1" dirty="0">
+                <a:solidFill>
+                  <a:srgbClr val="0F172A"/>
+                </a:solidFill>
+                <a:latin typeface="Google Sans Text" pitchFamily="34" charset="0"/>
+                <a:ea typeface="Google Sans Text" pitchFamily="34" charset="-122"/>
+                <a:cs typeface="Google Sans Text" pitchFamily="34" charset="-120"/>
+              </a:rPr>
+              <a:t>&lt;5s Valkey Purge + 423</a:t>
+            </a:r>
+            <a:endParaRPr lang="en-US" sz="830" dirty="0"/>
+          </a:p>
+        </p:txBody>
+      </p:sp>
+      <p:sp>
+        <p:nvSpPr>
+          <p:cNvPr id="69" name="Shape 67"/>
+          <p:cNvSpPr/>
+          <p:nvPr/>
+        </p:nvSpPr>
+        <p:spPr>
+          <a:xfrm>
+            <a:off x="6812280" y="5230368"/>
+            <a:ext cx="1737360" cy="804672"/>
+          </a:xfrm>
+          <a:prstGeom prst="roundRect">
+            <a:avLst>
+              <a:gd name="adj" fmla="val 6818"/>
+            </a:avLst>
+          </a:prstGeom>
+          <a:solidFill>
+            <a:srgbClr val="FFFFFF"/>
+          </a:solidFill>
+          <a:ln w="12700">
+            <a:solidFill>
+              <a:srgbClr val="D93025"/>
+            </a:solidFill>
+            <a:prstDash val="solid"/>
+          </a:ln>
+        </p:spPr>
+      </p:sp>
+      <p:sp>
+        <p:nvSpPr>
+          <p:cNvPr id="70" name="Text 68"/>
+          <p:cNvSpPr/>
+          <p:nvPr/>
+        </p:nvSpPr>
+        <p:spPr>
+          <a:xfrm>
+            <a:off x="6867144" y="5230368"/>
+            <a:ext cx="1627632" cy="804672"/>
+          </a:xfrm>
+          <a:prstGeom prst="rect">
+            <a:avLst/>
+          </a:prstGeom>
+          <a:noFill/>
+          <a:ln/>
+        </p:spPr>
+        <p:txBody>
+          <a:bodyPr wrap="square" rtlCol="0" anchor="ctr"/>
+          <a:lstStyle/>
+          <a:p>
+            <a:pPr algn="ctr" indent="0" marL="0">
+              <a:buNone/>
+            </a:pPr>
+            <a:r>
+              <a:rPr lang="en-US" sz="830" b="1" dirty="0">
+                <a:solidFill>
+                  <a:srgbClr val="0F172A"/>
+                </a:solidFill>
+                <a:latin typeface="Google Sans Text" pitchFamily="34" charset="0"/>
+                <a:ea typeface="Google Sans Text" pitchFamily="34" charset="-122"/>
+                <a:cs typeface="Google Sans Text" pitchFamily="34" charset="-120"/>
+              </a:rPr>
+              <a:t>Dedicated AlloyDB</a:t>
+            </a:r>
+            <a:endParaRPr lang="en-US" sz="830" dirty="0"/>
+          </a:p>
+          <a:p>
+            <a:pPr algn="ctr" indent="0" marL="0">
+              <a:buNone/>
+            </a:pPr>
+            <a:r>
+              <a:rPr lang="en-US" sz="830" b="1" dirty="0">
+                <a:solidFill>
+                  <a:srgbClr val="0F172A"/>
+                </a:solidFill>
+                <a:latin typeface="Google Sans Text" pitchFamily="34" charset="0"/>
+                <a:ea typeface="Google Sans Text" pitchFamily="34" charset="-122"/>
+                <a:cs typeface="Google Sans Text" pitchFamily="34" charset="-120"/>
+              </a:rPr>
+              <a:t>Unidirectional PSC Spoke</a:t>
+            </a:r>
+            <a:endParaRPr lang="en-US" sz="830" dirty="0"/>
+          </a:p>
+        </p:txBody>
+      </p:sp>
+      <p:sp>
+        <p:nvSpPr>
+          <p:cNvPr id="71" name="Shape 69"/>
+          <p:cNvSpPr/>
+          <p:nvPr/>
+        </p:nvSpPr>
+        <p:spPr>
+          <a:xfrm>
+            <a:off x="6675120" y="4681728"/>
+            <a:ext cx="137160" cy="0"/>
+          </a:xfrm>
+          <a:prstGeom prst="line">
+            <a:avLst/>
+          </a:prstGeom>
+          <a:noFill/>
+          <a:ln w="19050">
+            <a:solidFill>
+              <a:srgbClr val="D93025"/>
+            </a:solidFill>
+            <a:prstDash val="solid"/>
+            <a:tailEnd type="arrow"/>
+          </a:ln>
+        </p:spPr>
+      </p:sp>
+      <p:sp>
+        <p:nvSpPr>
+          <p:cNvPr id="72" name="Shape 70"/>
+          <p:cNvSpPr/>
+          <p:nvPr/>
+        </p:nvSpPr>
+        <p:spPr>
+          <a:xfrm>
+            <a:off x="5806440" y="5084064"/>
+            <a:ext cx="0" cy="146304"/>
+          </a:xfrm>
+          <a:prstGeom prst="line">
+            <a:avLst/>
+          </a:prstGeom>
+          <a:noFill/>
+          <a:ln w="19050">
+            <a:solidFill>
+              <a:srgbClr val="D93025"/>
+            </a:solidFill>
+            <a:prstDash val="solid"/>
+            <a:tailEnd type="arrow"/>
+          </a:ln>
+        </p:spPr>
+      </p:sp>
+      <p:sp>
+        <p:nvSpPr>
+          <p:cNvPr id="73" name="Shape 71"/>
+          <p:cNvSpPr/>
+          <p:nvPr/>
+        </p:nvSpPr>
+        <p:spPr>
+          <a:xfrm>
+            <a:off x="6675120" y="5632704"/>
+            <a:ext cx="137160" cy="0"/>
+          </a:xfrm>
+          <a:prstGeom prst="line">
+            <a:avLst/>
+          </a:prstGeom>
+          <a:noFill/>
+          <a:ln w="19050">
+            <a:solidFill>
+              <a:srgbClr val="D93025"/>
+            </a:solidFill>
+            <a:prstDash val="solid"/>
+            <a:tailEnd type="arrow"/>
+          </a:ln>
+        </p:spPr>
+      </p:sp>
+      <p:sp>
+        <p:nvSpPr>
+          <p:cNvPr id="74" name="Shape 72"/>
           <p:cNvSpPr/>
           <p:nvPr/>
         </p:nvSpPr>
@@ -20819,7 +22794,7 @@
       </p:sp>
       <p:sp>
         <p:nvSpPr>
-          <p:cNvPr id="19" name="Shape 16"/>
+          <p:cNvPr id="75" name="Shape 73"/>
           <p:cNvSpPr/>
           <p:nvPr/>
         </p:nvSpPr>
@@ -20844,7 +22819,7 @@
       </p:sp>
       <p:sp>
         <p:nvSpPr>
-          <p:cNvPr id="20" name="Text 17"/>
+          <p:cNvPr id="76" name="Text 74"/>
           <p:cNvSpPr/>
           <p:nvPr/>
         </p:nvSpPr>
@@ -20883,7 +22858,7 @@
       </p:sp>
       <p:sp>
         <p:nvSpPr>
-          <p:cNvPr id="21" name="Text 18"/>
+          <p:cNvPr id="77" name="Text 75"/>
           <p:cNvSpPr/>
           <p:nvPr/>
         </p:nvSpPr>
@@ -20922,7 +22897,7 @@
       </p:sp>
       <p:sp>
         <p:nvSpPr>
-          <p:cNvPr id="22" name="Shape 19"/>
+          <p:cNvPr id="78" name="Shape 76"/>
           <p:cNvSpPr/>
           <p:nvPr/>
         </p:nvSpPr>
@@ -20949,7 +22924,7 @@
       </p:sp>
       <p:sp>
         <p:nvSpPr>
-          <p:cNvPr id="23" name="Shape 20"/>
+          <p:cNvPr id="79" name="Shape 77"/>
           <p:cNvSpPr/>
           <p:nvPr/>
         </p:nvSpPr>
@@ -20974,7 +22949,7 @@
       </p:sp>
       <p:sp>
         <p:nvSpPr>
-          <p:cNvPr id="24" name="Text 21"/>
+          <p:cNvPr id="80" name="Text 78"/>
           <p:cNvSpPr/>
           <p:nvPr/>
         </p:nvSpPr>
@@ -21013,7 +22988,7 @@
       </p:sp>
       <p:sp>
         <p:nvSpPr>
-          <p:cNvPr id="25" name="Text 22"/>
+          <p:cNvPr id="81" name="Text 79"/>
           <p:cNvSpPr/>
           <p:nvPr/>
         </p:nvSpPr>
@@ -21052,7 +23027,7 @@
       </p:sp>
       <p:sp>
         <p:nvSpPr>
-          <p:cNvPr id="26" name="Shape 23"/>
+          <p:cNvPr id="82" name="Shape 80"/>
           <p:cNvSpPr/>
           <p:nvPr/>
         </p:nvSpPr>
@@ -21079,7 +23054,7 @@
       </p:sp>
       <p:sp>
         <p:nvSpPr>
-          <p:cNvPr id="27" name="Shape 24"/>
+          <p:cNvPr id="83" name="Shape 81"/>
           <p:cNvSpPr/>
           <p:nvPr/>
         </p:nvSpPr>
@@ -21104,7 +23079,7 @@
       </p:sp>
       <p:sp>
         <p:nvSpPr>
-          <p:cNvPr id="28" name="Text 25"/>
+          <p:cNvPr id="84" name="Text 82"/>
           <p:cNvSpPr/>
           <p:nvPr/>
         </p:nvSpPr>
@@ -21143,7 +23118,7 @@
       </p:sp>
       <p:sp>
         <p:nvSpPr>
-          <p:cNvPr id="29" name="Text 26"/>
+          <p:cNvPr id="85" name="Text 83"/>
           <p:cNvSpPr/>
           <p:nvPr/>
         </p:nvSpPr>
@@ -21182,7 +23157,7 @@
       </p:sp>
       <p:sp>
         <p:nvSpPr>
-          <p:cNvPr id="30" name="Shape 27"/>
+          <p:cNvPr id="86" name="Shape 84"/>
           <p:cNvSpPr/>
           <p:nvPr/>
         </p:nvSpPr>
@@ -21209,7 +23184,7 @@
       </p:sp>
       <p:sp>
         <p:nvSpPr>
-          <p:cNvPr id="31" name="Shape 28"/>
+          <p:cNvPr id="87" name="Shape 85"/>
           <p:cNvSpPr/>
           <p:nvPr/>
         </p:nvSpPr>
@@ -21234,7 +23209,7 @@
       </p:sp>
       <p:sp>
         <p:nvSpPr>
-          <p:cNvPr id="32" name="Text 29"/>
+          <p:cNvPr id="88" name="Text 86"/>
           <p:cNvSpPr/>
           <p:nvPr/>
         </p:nvSpPr>
@@ -21273,7 +23248,7 @@
       </p:sp>
       <p:sp>
         <p:nvSpPr>
-          <p:cNvPr id="33" name="Text 30"/>
+          <p:cNvPr id="89" name="Text 87"/>
           <p:cNvSpPr/>
           <p:nvPr/>
         </p:nvSpPr>
@@ -21568,7 +23543,7 @@
                 <a:ea typeface="Google Sans Display" pitchFamily="34" charset="-122"/>
                 <a:cs typeface="Google Sans Display" pitchFamily="34" charset="-120"/>
               </a:rPr>
-              <a:t>5 Zero-Trust Hops</a:t>
+              <a:t>100% Native Editable</a:t>
             </a:r>
             <a:endParaRPr lang="en-US" sz="950" dirty="0"/>
           </a:p>
@@ -21783,41 +23758,1555 @@
           <a:solidFill>
             <a:srgbClr val="FFFFFF"/>
           </a:solidFill>
-          <a:ln w="15240">
-            <a:solidFill>
-              <a:srgbClr val="CBD5E1"/>
-            </a:solidFill>
-            <a:prstDash val="solid"/>
-          </a:ln>
-        </p:spPr>
-      </p:sp>
-      <p:pic>
-        <p:nvPicPr>
-          <p:cNvPr id="17" name="Image 0" descr="/usr/local/google/home/nitinagga/Documents/blogs/diagrams/ws1-cloud-arch-center-5hop-baseline.drawio.png">    </p:cNvPr>
-          <p:cNvPicPr>
-            <a:picLocks noChangeAspect="1"/>
-          </p:cNvPicPr>
-          <p:nvPr/>
-        </p:nvPicPr>
-        <p:blipFill>
-          <a:blip r:embed="rId1"/>
-          <a:stretch>
-            <a:fillRect/>
-          </a:stretch>
-        </p:blipFill>
-        <p:spPr>
-          <a:xfrm>
-            <a:off x="2499970" y="1152144"/>
-            <a:ext cx="4373575" cy="5138928"/>
-          </a:xfrm>
-          <a:prstGeom prst="rect">
-            <a:avLst/>
-          </a:prstGeom>
-        </p:spPr>
-      </p:pic>
-      <p:sp>
-        <p:nvSpPr>
-          <p:cNvPr id="18" name="Shape 15"/>
+          <a:ln w="22225">
+            <a:solidFill>
+              <a:srgbClr val="1E8E3E"/>
+            </a:solidFill>
+            <a:prstDash val="solid"/>
+          </a:ln>
+        </p:spPr>
+      </p:sp>
+      <p:sp>
+        <p:nvSpPr>
+          <p:cNvPr id="17" name="Text 15"/>
+          <p:cNvSpPr/>
+          <p:nvPr/>
+        </p:nvSpPr>
+        <p:spPr>
+          <a:xfrm>
+            <a:off x="685800" y="1133856"/>
+            <a:ext cx="8001000" cy="256032"/>
+          </a:xfrm>
+          <a:prstGeom prst="rect">
+            <a:avLst/>
+          </a:prstGeom>
+          <a:noFill/>
+          <a:ln/>
+        </p:spPr>
+        <p:txBody>
+          <a:bodyPr wrap="square" rtlCol="0" anchor="ctr"/>
+          <a:lstStyle/>
+          <a:p>
+            <a:pPr indent="0" marL="0">
+              <a:buNone/>
+            </a:pPr>
+            <a:r>
+              <a:rPr lang="en-US" sz="950" b="1" dirty="0">
+                <a:solidFill>
+                  <a:srgbClr val="1E8E3E"/>
+                </a:solidFill>
+                <a:latin typeface="Google Sans Display" pitchFamily="34" charset="0"/>
+                <a:ea typeface="Google Sans Display" pitchFamily="34" charset="-122"/>
+                <a:cs typeface="Google Sans Display" pitchFamily="34" charset="-120"/>
+              </a:rPr>
+              <a:t>5-Hop Cryptographic Context Chain (KMS ECDSA P-256 Signed JWT)</a:t>
+            </a:r>
+            <a:endParaRPr lang="en-US" sz="950" dirty="0"/>
+          </a:p>
+        </p:txBody>
+      </p:sp>
+      <p:sp>
+        <p:nvSpPr>
+          <p:cNvPr id="18" name="Shape 16"/>
+          <p:cNvSpPr/>
+          <p:nvPr/>
+        </p:nvSpPr>
+        <p:spPr>
+          <a:xfrm>
+            <a:off x="685800" y="1481328"/>
+            <a:ext cx="1481328" cy="1261872"/>
+          </a:xfrm>
+          <a:prstGeom prst="roundRect">
+            <a:avLst>
+              <a:gd name="adj" fmla="val 5797"/>
+            </a:avLst>
+          </a:prstGeom>
+          <a:solidFill>
+            <a:srgbClr val="E8F0FE"/>
+          </a:solidFill>
+          <a:ln w="17780">
+            <a:solidFill>
+              <a:srgbClr val="1A73E8"/>
+            </a:solidFill>
+            <a:prstDash val="solid"/>
+          </a:ln>
+        </p:spPr>
+      </p:sp>
+      <p:sp>
+        <p:nvSpPr>
+          <p:cNvPr id="19" name="Text 17"/>
+          <p:cNvSpPr/>
+          <p:nvPr/>
+        </p:nvSpPr>
+        <p:spPr>
+          <a:xfrm>
+            <a:off x="740664" y="1536192"/>
+            <a:ext cx="1371600" cy="502920"/>
+          </a:xfrm>
+          <a:prstGeom prst="rect">
+            <a:avLst/>
+          </a:prstGeom>
+          <a:noFill/>
+          <a:ln/>
+        </p:spPr>
+        <p:txBody>
+          <a:bodyPr wrap="square" rtlCol="0" anchor="ctr"/>
+          <a:lstStyle/>
+          <a:p>
+            <a:pPr algn="ctr" indent="0" marL="0">
+              <a:buNone/>
+            </a:pPr>
+            <a:r>
+              <a:rPr lang="en-US" sz="920" b="1" dirty="0">
+                <a:solidFill>
+                  <a:srgbClr val="1A73E8"/>
+                </a:solidFill>
+                <a:latin typeface="Google Sans Display" pitchFamily="34" charset="0"/>
+                <a:ea typeface="Google Sans Display" pitchFamily="34" charset="-122"/>
+                <a:cs typeface="Google Sans Display" pitchFamily="34" charset="-120"/>
+              </a:rPr>
+              <a:t>HOP 1</a:t>
+            </a:r>
+            <a:endParaRPr lang="en-US" sz="920" dirty="0"/>
+          </a:p>
+          <a:p>
+            <a:pPr algn="ctr" indent="0" marL="0">
+              <a:buNone/>
+            </a:pPr>
+            <a:r>
+              <a:rPr lang="en-US" sz="920" b="1" dirty="0">
+                <a:solidFill>
+                  <a:srgbClr val="1A73E8"/>
+                </a:solidFill>
+                <a:latin typeface="Google Sans Display" pitchFamily="34" charset="0"/>
+                <a:ea typeface="Google Sans Display" pitchFamily="34" charset="-122"/>
+                <a:cs typeface="Google Sans Display" pitchFamily="34" charset="-120"/>
+              </a:rPr>
+              <a:t>Edge STS</a:t>
+            </a:r>
+            <a:endParaRPr lang="en-US" sz="920" dirty="0"/>
+          </a:p>
+        </p:txBody>
+      </p:sp>
+      <p:sp>
+        <p:nvSpPr>
+          <p:cNvPr id="20" name="Text 18"/>
+          <p:cNvSpPr/>
+          <p:nvPr/>
+        </p:nvSpPr>
+        <p:spPr>
+          <a:xfrm>
+            <a:off x="740664" y="2066544"/>
+            <a:ext cx="1371600" cy="594360"/>
+          </a:xfrm>
+          <a:prstGeom prst="rect">
+            <a:avLst/>
+          </a:prstGeom>
+          <a:noFill/>
+          <a:ln/>
+        </p:spPr>
+        <p:txBody>
+          <a:bodyPr wrap="square" rtlCol="0" anchor="ctr"/>
+          <a:lstStyle/>
+          <a:p>
+            <a:pPr algn="ctr" indent="0" marL="0">
+              <a:buNone/>
+            </a:pPr>
+            <a:r>
+              <a:rPr lang="en-US" sz="830" dirty="0">
+                <a:solidFill>
+                  <a:srgbClr val="0F172A"/>
+                </a:solidFill>
+                <a:latin typeface="Google Sans Text" pitchFamily="34" charset="0"/>
+                <a:ea typeface="Google Sans Text" pitchFamily="34" charset="-122"/>
+                <a:cs typeface="Google Sans Text" pitchFamily="34" charset="-120"/>
+              </a:rPr>
+              <a:t>OIDC + DPoP</a:t>
+            </a:r>
+            <a:endParaRPr lang="en-US" sz="830" dirty="0"/>
+          </a:p>
+          <a:p>
+            <a:pPr algn="ctr" indent="0" marL="0">
+              <a:buNone/>
+            </a:pPr>
+            <a:r>
+              <a:rPr lang="en-US" sz="830" dirty="0">
+                <a:solidFill>
+                  <a:srgbClr val="0F172A"/>
+                </a:solidFill>
+                <a:latin typeface="Google Sans Text" pitchFamily="34" charset="0"/>
+                <a:ea typeface="Google Sans Text" pitchFamily="34" charset="-122"/>
+                <a:cs typeface="Google Sans Text" pitchFamily="34" charset="-120"/>
+              </a:rPr>
+              <a:t>-&gt; KMS JWT</a:t>
+            </a:r>
+            <a:endParaRPr lang="en-US" sz="830" dirty="0"/>
+          </a:p>
+        </p:txBody>
+      </p:sp>
+      <p:sp>
+        <p:nvSpPr>
+          <p:cNvPr id="21" name="Shape 19"/>
+          <p:cNvSpPr/>
+          <p:nvPr/>
+        </p:nvSpPr>
+        <p:spPr>
+          <a:xfrm>
+            <a:off x="2167128" y="2112264"/>
+            <a:ext cx="137160" cy="0"/>
+          </a:xfrm>
+          <a:prstGeom prst="line">
+            <a:avLst/>
+          </a:prstGeom>
+          <a:noFill/>
+          <a:ln w="22225">
+            <a:solidFill>
+              <a:srgbClr val="1A73E8"/>
+            </a:solidFill>
+            <a:prstDash val="solid"/>
+            <a:tailEnd type="arrow"/>
+          </a:ln>
+        </p:spPr>
+      </p:sp>
+      <p:sp>
+        <p:nvSpPr>
+          <p:cNvPr id="22" name="Shape 20"/>
+          <p:cNvSpPr/>
+          <p:nvPr/>
+        </p:nvSpPr>
+        <p:spPr>
+          <a:xfrm>
+            <a:off x="2304288" y="1481328"/>
+            <a:ext cx="1481328" cy="1261872"/>
+          </a:xfrm>
+          <a:prstGeom prst="roundRect">
+            <a:avLst>
+              <a:gd name="adj" fmla="val 5797"/>
+            </a:avLst>
+          </a:prstGeom>
+          <a:solidFill>
+            <a:srgbClr val="E8F0FE"/>
+          </a:solidFill>
+          <a:ln w="17780">
+            <a:solidFill>
+              <a:srgbClr val="1A73E8"/>
+            </a:solidFill>
+            <a:prstDash val="solid"/>
+          </a:ln>
+        </p:spPr>
+      </p:sp>
+      <p:sp>
+        <p:nvSpPr>
+          <p:cNvPr id="23" name="Text 21"/>
+          <p:cNvSpPr/>
+          <p:nvPr/>
+        </p:nvSpPr>
+        <p:spPr>
+          <a:xfrm>
+            <a:off x="2359152" y="1536192"/>
+            <a:ext cx="1371600" cy="502920"/>
+          </a:xfrm>
+          <a:prstGeom prst="rect">
+            <a:avLst/>
+          </a:prstGeom>
+          <a:noFill/>
+          <a:ln/>
+        </p:spPr>
+        <p:txBody>
+          <a:bodyPr wrap="square" rtlCol="0" anchor="ctr"/>
+          <a:lstStyle/>
+          <a:p>
+            <a:pPr algn="ctr" indent="0" marL="0">
+              <a:buNone/>
+            </a:pPr>
+            <a:r>
+              <a:rPr lang="en-US" sz="920" b="1" dirty="0">
+                <a:solidFill>
+                  <a:srgbClr val="1A73E8"/>
+                </a:solidFill>
+                <a:latin typeface="Google Sans Display" pitchFamily="34" charset="0"/>
+                <a:ea typeface="Google Sans Display" pitchFamily="34" charset="-122"/>
+                <a:cs typeface="Google Sans Display" pitchFamily="34" charset="-120"/>
+              </a:rPr>
+              <a:t>HOP 2</a:t>
+            </a:r>
+            <a:endParaRPr lang="en-US" sz="920" dirty="0"/>
+          </a:p>
+          <a:p>
+            <a:pPr algn="ctr" indent="0" marL="0">
+              <a:buNone/>
+            </a:pPr>
+            <a:r>
+              <a:rPr lang="en-US" sz="920" b="1" dirty="0">
+                <a:solidFill>
+                  <a:srgbClr val="1A73E8"/>
+                </a:solidFill>
+                <a:latin typeface="Google Sans Display" pitchFamily="34" charset="0"/>
+                <a:ea typeface="Google Sans Display" pitchFamily="34" charset="-122"/>
+                <a:cs typeface="Google Sans Display" pitchFamily="34" charset="-120"/>
+              </a:rPr>
+              <a:t>ARD Scope</a:t>
+            </a:r>
+            <a:endParaRPr lang="en-US" sz="920" dirty="0"/>
+          </a:p>
+        </p:txBody>
+      </p:sp>
+      <p:sp>
+        <p:nvSpPr>
+          <p:cNvPr id="24" name="Text 22"/>
+          <p:cNvSpPr/>
+          <p:nvPr/>
+        </p:nvSpPr>
+        <p:spPr>
+          <a:xfrm>
+            <a:off x="2359152" y="2066544"/>
+            <a:ext cx="1371600" cy="594360"/>
+          </a:xfrm>
+          <a:prstGeom prst="rect">
+            <a:avLst/>
+          </a:prstGeom>
+          <a:noFill/>
+          <a:ln/>
+        </p:spPr>
+        <p:txBody>
+          <a:bodyPr wrap="square" rtlCol="0" anchor="ctr"/>
+          <a:lstStyle/>
+          <a:p>
+            <a:pPr algn="ctr" indent="0" marL="0">
+              <a:buNone/>
+            </a:pPr>
+            <a:r>
+              <a:rPr lang="en-US" sz="830" dirty="0">
+                <a:solidFill>
+                  <a:srgbClr val="0F172A"/>
+                </a:solidFill>
+                <a:latin typeface="Google Sans Text" pitchFamily="34" charset="0"/>
+                <a:ea typeface="Google Sans Text" pitchFamily="34" charset="-122"/>
+                <a:cs typeface="Google Sans Text" pitchFamily="34" charset="-120"/>
+              </a:rPr>
+              <a:t>Chrooted VFS</a:t>
+            </a:r>
+            <a:endParaRPr lang="en-US" sz="830" dirty="0"/>
+          </a:p>
+          <a:p>
+            <a:pPr algn="ctr" indent="0" marL="0">
+              <a:buNone/>
+            </a:pPr>
+            <a:r>
+              <a:rPr lang="en-US" sz="830" dirty="0">
+                <a:solidFill>
+                  <a:srgbClr val="0F172A"/>
+                </a:solidFill>
+                <a:latin typeface="Google Sans Text" pitchFamily="34" charset="0"/>
+                <a:ea typeface="Google Sans Text" pitchFamily="34" charset="-122"/>
+                <a:cs typeface="Google Sans Text" pitchFamily="34" charset="-120"/>
+              </a:rPr>
+              <a:t>&amp; 3LO Vault</a:t>
+            </a:r>
+            <a:endParaRPr lang="en-US" sz="830" dirty="0"/>
+          </a:p>
+        </p:txBody>
+      </p:sp>
+      <p:sp>
+        <p:nvSpPr>
+          <p:cNvPr id="25" name="Shape 23"/>
+          <p:cNvSpPr/>
+          <p:nvPr/>
+        </p:nvSpPr>
+        <p:spPr>
+          <a:xfrm>
+            <a:off x="3785616" y="2112264"/>
+            <a:ext cx="137160" cy="0"/>
+          </a:xfrm>
+          <a:prstGeom prst="line">
+            <a:avLst/>
+          </a:prstGeom>
+          <a:noFill/>
+          <a:ln w="22225">
+            <a:solidFill>
+              <a:srgbClr val="1A73E8"/>
+            </a:solidFill>
+            <a:prstDash val="solid"/>
+            <a:tailEnd type="arrow"/>
+          </a:ln>
+        </p:spPr>
+      </p:sp>
+      <p:sp>
+        <p:nvSpPr>
+          <p:cNvPr id="26" name="Shape 24"/>
+          <p:cNvSpPr/>
+          <p:nvPr/>
+        </p:nvSpPr>
+        <p:spPr>
+          <a:xfrm>
+            <a:off x="3922776" y="1481328"/>
+            <a:ext cx="1481328" cy="1261872"/>
+          </a:xfrm>
+          <a:prstGeom prst="roundRect">
+            <a:avLst>
+              <a:gd name="adj" fmla="val 5797"/>
+            </a:avLst>
+          </a:prstGeom>
+          <a:solidFill>
+            <a:srgbClr val="E6F4EA"/>
+          </a:solidFill>
+          <a:ln w="17780">
+            <a:solidFill>
+              <a:srgbClr val="1E8E3E"/>
+            </a:solidFill>
+            <a:prstDash val="solid"/>
+          </a:ln>
+        </p:spPr>
+      </p:sp>
+      <p:sp>
+        <p:nvSpPr>
+          <p:cNvPr id="27" name="Text 25"/>
+          <p:cNvSpPr/>
+          <p:nvPr/>
+        </p:nvSpPr>
+        <p:spPr>
+          <a:xfrm>
+            <a:off x="3977640" y="1536192"/>
+            <a:ext cx="1371600" cy="502920"/>
+          </a:xfrm>
+          <a:prstGeom prst="rect">
+            <a:avLst/>
+          </a:prstGeom>
+          <a:noFill/>
+          <a:ln/>
+        </p:spPr>
+        <p:txBody>
+          <a:bodyPr wrap="square" rtlCol="0" anchor="ctr"/>
+          <a:lstStyle/>
+          <a:p>
+            <a:pPr algn="ctr" indent="0" marL="0">
+              <a:buNone/>
+            </a:pPr>
+            <a:r>
+              <a:rPr lang="en-US" sz="920" b="1" dirty="0">
+                <a:solidFill>
+                  <a:srgbClr val="1E8E3E"/>
+                </a:solidFill>
+                <a:latin typeface="Google Sans Display" pitchFamily="34" charset="0"/>
+                <a:ea typeface="Google Sans Display" pitchFamily="34" charset="-122"/>
+                <a:cs typeface="Google Sans Display" pitchFamily="34" charset="-120"/>
+              </a:rPr>
+              <a:t>HOP 3</a:t>
+            </a:r>
+            <a:endParaRPr lang="en-US" sz="920" dirty="0"/>
+          </a:p>
+          <a:p>
+            <a:pPr algn="ctr" indent="0" marL="0">
+              <a:buNone/>
+            </a:pPr>
+            <a:r>
+              <a:rPr lang="en-US" sz="920" b="1" dirty="0">
+                <a:solidFill>
+                  <a:srgbClr val="1E8E3E"/>
+                </a:solidFill>
+                <a:latin typeface="Google Sans Display" pitchFamily="34" charset="0"/>
+                <a:ea typeface="Google Sans Display" pitchFamily="34" charset="-122"/>
+                <a:cs typeface="Google Sans Display" pitchFamily="34" charset="-120"/>
+              </a:rPr>
+              <a:t>Valkey L1</a:t>
+            </a:r>
+            <a:endParaRPr lang="en-US" sz="920" dirty="0"/>
+          </a:p>
+        </p:txBody>
+      </p:sp>
+      <p:sp>
+        <p:nvSpPr>
+          <p:cNvPr id="28" name="Text 26"/>
+          <p:cNvSpPr/>
+          <p:nvPr/>
+        </p:nvSpPr>
+        <p:spPr>
+          <a:xfrm>
+            <a:off x="3977640" y="2066544"/>
+            <a:ext cx="1371600" cy="594360"/>
+          </a:xfrm>
+          <a:prstGeom prst="rect">
+            <a:avLst/>
+          </a:prstGeom>
+          <a:noFill/>
+          <a:ln/>
+        </p:spPr>
+        <p:txBody>
+          <a:bodyPr wrap="square" rtlCol="0" anchor="ctr"/>
+          <a:lstStyle/>
+          <a:p>
+            <a:pPr algn="ctr" indent="0" marL="0">
+              <a:buNone/>
+            </a:pPr>
+            <a:r>
+              <a:rPr lang="en-US" sz="830" dirty="0">
+                <a:solidFill>
+                  <a:srgbClr val="0F172A"/>
+                </a:solidFill>
+                <a:latin typeface="Google Sans Text" pitchFamily="34" charset="0"/>
+                <a:ea typeface="Google Sans Text" pitchFamily="34" charset="-122"/>
+                <a:cs typeface="Google Sans Text" pitchFamily="34" charset="-120"/>
+              </a:rPr>
+              <a:t>&lt;5s Key Purge</a:t>
+            </a:r>
+            <a:endParaRPr lang="en-US" sz="830" dirty="0"/>
+          </a:p>
+          <a:p>
+            <a:pPr algn="ctr" indent="0" marL="0">
+              <a:buNone/>
+            </a:pPr>
+            <a:r>
+              <a:rPr lang="en-US" sz="830" dirty="0">
+                <a:solidFill>
+                  <a:srgbClr val="0F172A"/>
+                </a:solidFill>
+                <a:latin typeface="Google Sans Text" pitchFamily="34" charset="0"/>
+                <a:ea typeface="Google Sans Text" pitchFamily="34" charset="-122"/>
+                <a:cs typeface="Google Sans Text" pitchFamily="34" charset="-120"/>
+              </a:rPr>
+              <a:t>&amp; RPM Quota</a:t>
+            </a:r>
+            <a:endParaRPr lang="en-US" sz="830" dirty="0"/>
+          </a:p>
+        </p:txBody>
+      </p:sp>
+      <p:sp>
+        <p:nvSpPr>
+          <p:cNvPr id="29" name="Shape 27"/>
+          <p:cNvSpPr/>
+          <p:nvPr/>
+        </p:nvSpPr>
+        <p:spPr>
+          <a:xfrm>
+            <a:off x="5404104" y="2112264"/>
+            <a:ext cx="137160" cy="0"/>
+          </a:xfrm>
+          <a:prstGeom prst="line">
+            <a:avLst/>
+          </a:prstGeom>
+          <a:noFill/>
+          <a:ln w="22225">
+            <a:solidFill>
+              <a:srgbClr val="1E8E3E"/>
+            </a:solidFill>
+            <a:prstDash val="solid"/>
+            <a:tailEnd type="arrow"/>
+          </a:ln>
+        </p:spPr>
+      </p:sp>
+      <p:sp>
+        <p:nvSpPr>
+          <p:cNvPr id="30" name="Shape 28"/>
+          <p:cNvSpPr/>
+          <p:nvPr/>
+        </p:nvSpPr>
+        <p:spPr>
+          <a:xfrm>
+            <a:off x="5541264" y="1481328"/>
+            <a:ext cx="1481328" cy="1261872"/>
+          </a:xfrm>
+          <a:prstGeom prst="roundRect">
+            <a:avLst>
+              <a:gd name="adj" fmla="val 5797"/>
+            </a:avLst>
+          </a:prstGeom>
+          <a:solidFill>
+            <a:srgbClr val="FEF7E0"/>
+          </a:solidFill>
+          <a:ln w="17780">
+            <a:solidFill>
+              <a:srgbClr val="B06000"/>
+            </a:solidFill>
+            <a:prstDash val="solid"/>
+          </a:ln>
+        </p:spPr>
+      </p:sp>
+      <p:sp>
+        <p:nvSpPr>
+          <p:cNvPr id="31" name="Text 29"/>
+          <p:cNvSpPr/>
+          <p:nvPr/>
+        </p:nvSpPr>
+        <p:spPr>
+          <a:xfrm>
+            <a:off x="5596128" y="1536192"/>
+            <a:ext cx="1371600" cy="502920"/>
+          </a:xfrm>
+          <a:prstGeom prst="rect">
+            <a:avLst/>
+          </a:prstGeom>
+          <a:noFill/>
+          <a:ln/>
+        </p:spPr>
+        <p:txBody>
+          <a:bodyPr wrap="square" rtlCol="0" anchor="ctr"/>
+          <a:lstStyle/>
+          <a:p>
+            <a:pPr algn="ctr" indent="0" marL="0">
+              <a:buNone/>
+            </a:pPr>
+            <a:r>
+              <a:rPr lang="en-US" sz="920" b="1" dirty="0">
+                <a:solidFill>
+                  <a:srgbClr val="B06000"/>
+                </a:solidFill>
+                <a:latin typeface="Google Sans Display" pitchFamily="34" charset="0"/>
+                <a:ea typeface="Google Sans Display" pitchFamily="34" charset="-122"/>
+                <a:cs typeface="Google Sans Display" pitchFamily="34" charset="-120"/>
+              </a:rPr>
+              <a:t>HOP 4</a:t>
+            </a:r>
+            <a:endParaRPr lang="en-US" sz="920" dirty="0"/>
+          </a:p>
+          <a:p>
+            <a:pPr algn="ctr" indent="0" marL="0">
+              <a:buNone/>
+            </a:pPr>
+            <a:r>
+              <a:rPr lang="en-US" sz="920" b="1" dirty="0">
+                <a:solidFill>
+                  <a:srgbClr val="B06000"/>
+                </a:solidFill>
+                <a:latin typeface="Google Sans Display" pitchFamily="34" charset="0"/>
+                <a:ea typeface="Google Sans Display" pitchFamily="34" charset="-122"/>
+                <a:cs typeface="Google Sans Display" pitchFamily="34" charset="-120"/>
+              </a:rPr>
+              <a:t>Model Armor</a:t>
+            </a:r>
+            <a:endParaRPr lang="en-US" sz="920" dirty="0"/>
+          </a:p>
+        </p:txBody>
+      </p:sp>
+      <p:sp>
+        <p:nvSpPr>
+          <p:cNvPr id="32" name="Text 30"/>
+          <p:cNvSpPr/>
+          <p:nvPr/>
+        </p:nvSpPr>
+        <p:spPr>
+          <a:xfrm>
+            <a:off x="5596128" y="2066544"/>
+            <a:ext cx="1371600" cy="594360"/>
+          </a:xfrm>
+          <a:prstGeom prst="rect">
+            <a:avLst/>
+          </a:prstGeom>
+          <a:noFill/>
+          <a:ln/>
+        </p:spPr>
+        <p:txBody>
+          <a:bodyPr wrap="square" rtlCol="0" anchor="ctr"/>
+          <a:lstStyle/>
+          <a:p>
+            <a:pPr algn="ctr" indent="0" marL="0">
+              <a:buNone/>
+            </a:pPr>
+            <a:r>
+              <a:rPr lang="en-US" sz="830" dirty="0">
+                <a:solidFill>
+                  <a:srgbClr val="0F172A"/>
+                </a:solidFill>
+                <a:latin typeface="Google Sans Text" pitchFamily="34" charset="0"/>
+                <a:ea typeface="Google Sans Text" pitchFamily="34" charset="-122"/>
+                <a:cs typeface="Google Sans Text" pitchFamily="34" charset="-120"/>
+              </a:rPr>
+              <a:t>Inline DLP &amp;</a:t>
+            </a:r>
+            <a:endParaRPr lang="en-US" sz="830" dirty="0"/>
+          </a:p>
+          <a:p>
+            <a:pPr algn="ctr" indent="0" marL="0">
+              <a:buNone/>
+            </a:pPr>
+            <a:r>
+              <a:rPr lang="en-US" sz="830" dirty="0">
+                <a:solidFill>
+                  <a:srgbClr val="0F172A"/>
+                </a:solidFill>
+                <a:latin typeface="Google Sans Text" pitchFamily="34" charset="0"/>
+                <a:ea typeface="Google Sans Text" pitchFamily="34" charset="-122"/>
+                <a:cs typeface="Google Sans Text" pitchFamily="34" charset="-120"/>
+              </a:rPr>
+              <a:t>NLC Guard</a:t>
+            </a:r>
+            <a:endParaRPr lang="en-US" sz="830" dirty="0"/>
+          </a:p>
+        </p:txBody>
+      </p:sp>
+      <p:sp>
+        <p:nvSpPr>
+          <p:cNvPr id="33" name="Shape 31"/>
+          <p:cNvSpPr/>
+          <p:nvPr/>
+        </p:nvSpPr>
+        <p:spPr>
+          <a:xfrm>
+            <a:off x="7022592" y="2112264"/>
+            <a:ext cx="137160" cy="0"/>
+          </a:xfrm>
+          <a:prstGeom prst="line">
+            <a:avLst/>
+          </a:prstGeom>
+          <a:noFill/>
+          <a:ln w="22225">
+            <a:solidFill>
+              <a:srgbClr val="B06000"/>
+            </a:solidFill>
+            <a:prstDash val="solid"/>
+            <a:tailEnd type="arrow"/>
+          </a:ln>
+        </p:spPr>
+      </p:sp>
+      <p:sp>
+        <p:nvSpPr>
+          <p:cNvPr id="34" name="Shape 32"/>
+          <p:cNvSpPr/>
+          <p:nvPr/>
+        </p:nvSpPr>
+        <p:spPr>
+          <a:xfrm>
+            <a:off x="7159752" y="1481328"/>
+            <a:ext cx="1481328" cy="1261872"/>
+          </a:xfrm>
+          <a:prstGeom prst="roundRect">
+            <a:avLst>
+              <a:gd name="adj" fmla="val 5797"/>
+            </a:avLst>
+          </a:prstGeom>
+          <a:solidFill>
+            <a:srgbClr val="FCE8E6"/>
+          </a:solidFill>
+          <a:ln w="17780">
+            <a:solidFill>
+              <a:srgbClr val="D93025"/>
+            </a:solidFill>
+            <a:prstDash val="solid"/>
+          </a:ln>
+        </p:spPr>
+      </p:sp>
+      <p:sp>
+        <p:nvSpPr>
+          <p:cNvPr id="35" name="Text 33"/>
+          <p:cNvSpPr/>
+          <p:nvPr/>
+        </p:nvSpPr>
+        <p:spPr>
+          <a:xfrm>
+            <a:off x="7214616" y="1536192"/>
+            <a:ext cx="1371600" cy="502920"/>
+          </a:xfrm>
+          <a:prstGeom prst="rect">
+            <a:avLst/>
+          </a:prstGeom>
+          <a:noFill/>
+          <a:ln/>
+        </p:spPr>
+        <p:txBody>
+          <a:bodyPr wrap="square" rtlCol="0" anchor="ctr"/>
+          <a:lstStyle/>
+          <a:p>
+            <a:pPr algn="ctr" indent="0" marL="0">
+              <a:buNone/>
+            </a:pPr>
+            <a:r>
+              <a:rPr lang="en-US" sz="920" b="1" dirty="0">
+                <a:solidFill>
+                  <a:srgbClr val="D93025"/>
+                </a:solidFill>
+                <a:latin typeface="Google Sans Display" pitchFamily="34" charset="0"/>
+                <a:ea typeface="Google Sans Display" pitchFamily="34" charset="-122"/>
+                <a:cs typeface="Google Sans Display" pitchFamily="34" charset="-120"/>
+              </a:rPr>
+              <a:t>HOP 5</a:t>
+            </a:r>
+            <a:endParaRPr lang="en-US" sz="920" dirty="0"/>
+          </a:p>
+          <a:p>
+            <a:pPr algn="ctr" indent="0" marL="0">
+              <a:buNone/>
+            </a:pPr>
+            <a:r>
+              <a:rPr lang="en-US" sz="920" b="1" dirty="0">
+                <a:solidFill>
+                  <a:srgbClr val="D93025"/>
+                </a:solidFill>
+                <a:latin typeface="Google Sans Display" pitchFamily="34" charset="0"/>
+                <a:ea typeface="Google Sans Display" pitchFamily="34" charset="-122"/>
+                <a:cs typeface="Google Sans Display" pitchFamily="34" charset="-120"/>
+              </a:rPr>
+              <a:t>AlloyDB RLS</a:t>
+            </a:r>
+            <a:endParaRPr lang="en-US" sz="920" dirty="0"/>
+          </a:p>
+        </p:txBody>
+      </p:sp>
+      <p:sp>
+        <p:nvSpPr>
+          <p:cNvPr id="36" name="Text 34"/>
+          <p:cNvSpPr/>
+          <p:nvPr/>
+        </p:nvSpPr>
+        <p:spPr>
+          <a:xfrm>
+            <a:off x="7214616" y="2066544"/>
+            <a:ext cx="1371600" cy="594360"/>
+          </a:xfrm>
+          <a:prstGeom prst="rect">
+            <a:avLst/>
+          </a:prstGeom>
+          <a:noFill/>
+          <a:ln/>
+        </p:spPr>
+        <p:txBody>
+          <a:bodyPr wrap="square" rtlCol="0" anchor="ctr"/>
+          <a:lstStyle/>
+          <a:p>
+            <a:pPr algn="ctr" indent="0" marL="0">
+              <a:buNone/>
+            </a:pPr>
+            <a:r>
+              <a:rPr lang="en-US" sz="830" dirty="0">
+                <a:solidFill>
+                  <a:srgbClr val="0F172A"/>
+                </a:solidFill>
+                <a:latin typeface="Google Sans Text" pitchFamily="34" charset="0"/>
+                <a:ea typeface="Google Sans Text" pitchFamily="34" charset="-122"/>
+                <a:cs typeface="Google Sans Text" pitchFamily="34" charset="-120"/>
+              </a:rPr>
+              <a:t>SET LOCAL</a:t>
+            </a:r>
+            <a:endParaRPr lang="en-US" sz="830" dirty="0"/>
+          </a:p>
+          <a:p>
+            <a:pPr algn="ctr" indent="0" marL="0">
+              <a:buNone/>
+            </a:pPr>
+            <a:r>
+              <a:rPr lang="en-US" sz="830" dirty="0">
+                <a:solidFill>
+                  <a:srgbClr val="0F172A"/>
+                </a:solidFill>
+                <a:latin typeface="Google Sans Text" pitchFamily="34" charset="0"/>
+                <a:ea typeface="Google Sans Text" pitchFamily="34" charset="-122"/>
+                <a:cs typeface="Google Sans Text" pitchFamily="34" charset="-120"/>
+              </a:rPr>
+              <a:t>tenant_id</a:t>
+            </a:r>
+            <a:endParaRPr lang="en-US" sz="830" dirty="0"/>
+          </a:p>
+        </p:txBody>
+      </p:sp>
+      <p:sp>
+        <p:nvSpPr>
+          <p:cNvPr id="37" name="Shape 35"/>
+          <p:cNvSpPr/>
+          <p:nvPr/>
+        </p:nvSpPr>
+        <p:spPr>
+          <a:xfrm>
+            <a:off x="2606040" y="2743200"/>
+            <a:ext cx="0" cy="438912"/>
+          </a:xfrm>
+          <a:prstGeom prst="line">
+            <a:avLst/>
+          </a:prstGeom>
+          <a:noFill/>
+          <a:ln w="25400">
+            <a:solidFill>
+              <a:srgbClr val="D93025"/>
+            </a:solidFill>
+            <a:prstDash val="solid"/>
+            <a:tailEnd type="arrow"/>
+          </a:ln>
+        </p:spPr>
+      </p:sp>
+      <p:sp>
+        <p:nvSpPr>
+          <p:cNvPr id="38" name="Shape 36"/>
+          <p:cNvSpPr/>
+          <p:nvPr/>
+        </p:nvSpPr>
+        <p:spPr>
+          <a:xfrm>
+            <a:off x="6537960" y="2743200"/>
+            <a:ext cx="0" cy="438912"/>
+          </a:xfrm>
+          <a:prstGeom prst="line">
+            <a:avLst/>
+          </a:prstGeom>
+          <a:noFill/>
+          <a:ln w="25400">
+            <a:solidFill>
+              <a:srgbClr val="B06000"/>
+            </a:solidFill>
+            <a:prstDash val="solid"/>
+            <a:tailEnd type="arrow"/>
+          </a:ln>
+        </p:spPr>
+      </p:sp>
+      <p:sp>
+        <p:nvSpPr>
+          <p:cNvPr id="39" name="Shape 37"/>
+          <p:cNvSpPr/>
+          <p:nvPr/>
+        </p:nvSpPr>
+        <p:spPr>
+          <a:xfrm>
+            <a:off x="685800" y="3182112"/>
+            <a:ext cx="3886200" cy="3017520"/>
+          </a:xfrm>
+          <a:prstGeom prst="roundRect">
+            <a:avLst>
+              <a:gd name="adj" fmla="val 2727"/>
+            </a:avLst>
+          </a:prstGeom>
+          <a:solidFill>
+            <a:srgbClr val="FCE8E6"/>
+          </a:solidFill>
+          <a:ln w="17780">
+            <a:solidFill>
+              <a:srgbClr val="D93025"/>
+            </a:solidFill>
+            <a:prstDash val="solid"/>
+          </a:ln>
+        </p:spPr>
+      </p:sp>
+      <p:sp>
+        <p:nvSpPr>
+          <p:cNvPr id="40" name="Text 38"/>
+          <p:cNvSpPr/>
+          <p:nvPr/>
+        </p:nvSpPr>
+        <p:spPr>
+          <a:xfrm>
+            <a:off x="822960" y="3255264"/>
+            <a:ext cx="3611880" cy="256032"/>
+          </a:xfrm>
+          <a:prstGeom prst="rect">
+            <a:avLst/>
+          </a:prstGeom>
+          <a:noFill/>
+          <a:ln/>
+        </p:spPr>
+        <p:txBody>
+          <a:bodyPr wrap="square" rtlCol="0" anchor="ctr"/>
+          <a:lstStyle/>
+          <a:p>
+            <a:pPr indent="0" marL="0">
+              <a:buNone/>
+            </a:pPr>
+            <a:r>
+              <a:rPr lang="en-US" sz="920" b="1" dirty="0">
+                <a:solidFill>
+                  <a:srgbClr val="D93025"/>
+                </a:solidFill>
+                <a:latin typeface="Google Sans Display" pitchFamily="34" charset="0"/>
+                <a:ea typeface="Google Sans Display" pitchFamily="34" charset="-122"/>
+                <a:cs typeface="Google Sans Display" pitchFamily="34" charset="-120"/>
+              </a:rPr>
+              <a:t>Tenant Alpha • FinVault Bank (Enterprise Silo)</a:t>
+            </a:r>
+            <a:endParaRPr lang="en-US" sz="920" dirty="0"/>
+          </a:p>
+        </p:txBody>
+      </p:sp>
+      <p:sp>
+        <p:nvSpPr>
+          <p:cNvPr id="41" name="Shape 39"/>
+          <p:cNvSpPr/>
+          <p:nvPr/>
+        </p:nvSpPr>
+        <p:spPr>
+          <a:xfrm>
+            <a:off x="841248" y="3602736"/>
+            <a:ext cx="3575304" cy="493776"/>
+          </a:xfrm>
+          <a:prstGeom prst="roundRect">
+            <a:avLst>
+              <a:gd name="adj" fmla="val 11111"/>
+            </a:avLst>
+          </a:prstGeom>
+          <a:solidFill>
+            <a:srgbClr val="FFFFFF"/>
+          </a:solidFill>
+          <a:ln w="11430">
+            <a:solidFill>
+              <a:srgbClr val="D93025"/>
+            </a:solidFill>
+            <a:prstDash val="solid"/>
+          </a:ln>
+        </p:spPr>
+      </p:sp>
+      <p:sp>
+        <p:nvSpPr>
+          <p:cNvPr id="42" name="Text 40"/>
+          <p:cNvSpPr/>
+          <p:nvPr/>
+        </p:nvSpPr>
+        <p:spPr>
+          <a:xfrm>
+            <a:off x="950976" y="3602736"/>
+            <a:ext cx="3355848" cy="493776"/>
+          </a:xfrm>
+          <a:prstGeom prst="rect">
+            <a:avLst/>
+          </a:prstGeom>
+          <a:noFill/>
+          <a:ln/>
+        </p:spPr>
+        <p:txBody>
+          <a:bodyPr wrap="square" rtlCol="0" anchor="ctr"/>
+          <a:lstStyle/>
+          <a:p>
+            <a:pPr indent="0" marL="0">
+              <a:buNone/>
+            </a:pPr>
+            <a:r>
+              <a:rPr lang="en-US" sz="860" b="1" dirty="0">
+                <a:solidFill>
+                  <a:srgbClr val="0F172A"/>
+                </a:solidFill>
+                <a:latin typeface="Google Sans Text" pitchFamily="34" charset="0"/>
+                <a:ea typeface="Google Sans Text" pitchFamily="34" charset="-122"/>
+                <a:cs typeface="Google Sans Text" pitchFamily="34" charset="-120"/>
+              </a:rPr>
+              <a:t>• JWT Claim: tenant_id="finvault", tier="ENTERPRISE"</a:t>
+            </a:r>
+            <a:endParaRPr lang="en-US" sz="860" dirty="0"/>
+          </a:p>
+        </p:txBody>
+      </p:sp>
+      <p:sp>
+        <p:nvSpPr>
+          <p:cNvPr id="43" name="Shape 41"/>
+          <p:cNvSpPr/>
+          <p:nvPr/>
+        </p:nvSpPr>
+        <p:spPr>
+          <a:xfrm>
+            <a:off x="841248" y="4224528"/>
+            <a:ext cx="3575304" cy="493776"/>
+          </a:xfrm>
+          <a:prstGeom prst="roundRect">
+            <a:avLst>
+              <a:gd name="adj" fmla="val 11111"/>
+            </a:avLst>
+          </a:prstGeom>
+          <a:solidFill>
+            <a:srgbClr val="FFFFFF"/>
+          </a:solidFill>
+          <a:ln w="11430">
+            <a:solidFill>
+              <a:srgbClr val="D93025"/>
+            </a:solidFill>
+            <a:prstDash val="solid"/>
+          </a:ln>
+        </p:spPr>
+      </p:sp>
+      <p:sp>
+        <p:nvSpPr>
+          <p:cNvPr id="44" name="Text 42"/>
+          <p:cNvSpPr/>
+          <p:nvPr/>
+        </p:nvSpPr>
+        <p:spPr>
+          <a:xfrm>
+            <a:off x="950976" y="4224528"/>
+            <a:ext cx="3355848" cy="493776"/>
+          </a:xfrm>
+          <a:prstGeom prst="rect">
+            <a:avLst/>
+          </a:prstGeom>
+          <a:noFill/>
+          <a:ln/>
+        </p:spPr>
+        <p:txBody>
+          <a:bodyPr wrap="square" rtlCol="0" anchor="ctr"/>
+          <a:lstStyle/>
+          <a:p>
+            <a:pPr indent="0" marL="0">
+              <a:buNone/>
+            </a:pPr>
+            <a:r>
+              <a:rPr lang="en-US" sz="860" b="1" dirty="0">
+                <a:solidFill>
+                  <a:srgbClr val="0F172A"/>
+                </a:solidFill>
+                <a:latin typeface="Google Sans Text" pitchFamily="34" charset="0"/>
+                <a:ea typeface="Google Sans Text" pitchFamily="34" charset="-122"/>
+                <a:cs typeface="Google Sans Text" pitchFamily="34" charset="-120"/>
+              </a:rPr>
+              <a:t>• Agent Engine: Private Agent Alpha + 8k Thinking</a:t>
+            </a:r>
+            <a:endParaRPr lang="en-US" sz="860" dirty="0"/>
+          </a:p>
+        </p:txBody>
+      </p:sp>
+      <p:sp>
+        <p:nvSpPr>
+          <p:cNvPr id="45" name="Shape 43"/>
+          <p:cNvSpPr/>
+          <p:nvPr/>
+        </p:nvSpPr>
+        <p:spPr>
+          <a:xfrm>
+            <a:off x="841248" y="4846320"/>
+            <a:ext cx="3575304" cy="493776"/>
+          </a:xfrm>
+          <a:prstGeom prst="roundRect">
+            <a:avLst>
+              <a:gd name="adj" fmla="val 11111"/>
+            </a:avLst>
+          </a:prstGeom>
+          <a:solidFill>
+            <a:srgbClr val="FFFFFF"/>
+          </a:solidFill>
+          <a:ln w="11430">
+            <a:solidFill>
+              <a:srgbClr val="D93025"/>
+            </a:solidFill>
+            <a:prstDash val="solid"/>
+          </a:ln>
+        </p:spPr>
+      </p:sp>
+      <p:sp>
+        <p:nvSpPr>
+          <p:cNvPr id="46" name="Text 44"/>
+          <p:cNvSpPr/>
+          <p:nvPr/>
+        </p:nvSpPr>
+        <p:spPr>
+          <a:xfrm>
+            <a:off x="950976" y="4846320"/>
+            <a:ext cx="3355848" cy="493776"/>
+          </a:xfrm>
+          <a:prstGeom prst="rect">
+            <a:avLst/>
+          </a:prstGeom>
+          <a:noFill/>
+          <a:ln/>
+        </p:spPr>
+        <p:txBody>
+          <a:bodyPr wrap="square" rtlCol="0" anchor="ctr"/>
+          <a:lstStyle/>
+          <a:p>
+            <a:pPr indent="0" marL="0">
+              <a:buNone/>
+            </a:pPr>
+            <a:r>
+              <a:rPr lang="en-US" sz="860" b="1" dirty="0">
+                <a:solidFill>
+                  <a:srgbClr val="0F172A"/>
+                </a:solidFill>
+                <a:latin typeface="Google Sans Text" pitchFamily="34" charset="0"/>
+                <a:ea typeface="Google Sans Text" pitchFamily="34" charset="-122"/>
+                <a:cs typeface="Google Sans Text" pitchFamily="34" charset="-120"/>
+              </a:rPr>
+              <a:t>• MCP Tools: Workspace + Jira 3LO (DPoP-bound)</a:t>
+            </a:r>
+            <a:endParaRPr lang="en-US" sz="860" dirty="0"/>
+          </a:p>
+        </p:txBody>
+      </p:sp>
+      <p:sp>
+        <p:nvSpPr>
+          <p:cNvPr id="47" name="Shape 45"/>
+          <p:cNvSpPr/>
+          <p:nvPr/>
+        </p:nvSpPr>
+        <p:spPr>
+          <a:xfrm>
+            <a:off x="841248" y="5468112"/>
+            <a:ext cx="3575304" cy="493776"/>
+          </a:xfrm>
+          <a:prstGeom prst="roundRect">
+            <a:avLst>
+              <a:gd name="adj" fmla="val 11111"/>
+            </a:avLst>
+          </a:prstGeom>
+          <a:solidFill>
+            <a:srgbClr val="FFFFFF"/>
+          </a:solidFill>
+          <a:ln w="11430">
+            <a:solidFill>
+              <a:srgbClr val="D93025"/>
+            </a:solidFill>
+            <a:prstDash val="solid"/>
+          </a:ln>
+        </p:spPr>
+      </p:sp>
+      <p:sp>
+        <p:nvSpPr>
+          <p:cNvPr id="48" name="Text 46"/>
+          <p:cNvSpPr/>
+          <p:nvPr/>
+        </p:nvSpPr>
+        <p:spPr>
+          <a:xfrm>
+            <a:off x="950976" y="5468112"/>
+            <a:ext cx="3355848" cy="493776"/>
+          </a:xfrm>
+          <a:prstGeom prst="rect">
+            <a:avLst/>
+          </a:prstGeom>
+          <a:noFill/>
+          <a:ln/>
+        </p:spPr>
+        <p:txBody>
+          <a:bodyPr wrap="square" rtlCol="0" anchor="ctr"/>
+          <a:lstStyle/>
+          <a:p>
+            <a:pPr indent="0" marL="0">
+              <a:buNone/>
+            </a:pPr>
+            <a:r>
+              <a:rPr lang="en-US" sz="860" b="1" dirty="0">
+                <a:solidFill>
+                  <a:srgbClr val="0F172A"/>
+                </a:solidFill>
+                <a:latin typeface="Google Sans Text" pitchFamily="34" charset="0"/>
+                <a:ea typeface="Google Sans Text" pitchFamily="34" charset="-122"/>
+                <a:cs typeface="Google Sans Text" pitchFamily="34" charset="-120"/>
+              </a:rPr>
+              <a:t>• Datastore: Dedicated AlloyDB + Customer KMS Key</a:t>
+            </a:r>
+            <a:endParaRPr lang="en-US" sz="860" dirty="0"/>
+          </a:p>
+        </p:txBody>
+      </p:sp>
+      <p:sp>
+        <p:nvSpPr>
+          <p:cNvPr id="49" name="Shape 47"/>
+          <p:cNvSpPr/>
+          <p:nvPr/>
+        </p:nvSpPr>
+        <p:spPr>
+          <a:xfrm>
+            <a:off x="4800600" y="3182112"/>
+            <a:ext cx="3886200" cy="3017520"/>
+          </a:xfrm>
+          <a:prstGeom prst="roundRect">
+            <a:avLst>
+              <a:gd name="adj" fmla="val 2727"/>
+            </a:avLst>
+          </a:prstGeom>
+          <a:solidFill>
+            <a:srgbClr val="FEF7E0"/>
+          </a:solidFill>
+          <a:ln w="17780">
+            <a:solidFill>
+              <a:srgbClr val="B06000"/>
+            </a:solidFill>
+            <a:prstDash val="solid"/>
+          </a:ln>
+        </p:spPr>
+      </p:sp>
+      <p:sp>
+        <p:nvSpPr>
+          <p:cNvPr id="50" name="Text 48"/>
+          <p:cNvSpPr/>
+          <p:nvPr/>
+        </p:nvSpPr>
+        <p:spPr>
+          <a:xfrm>
+            <a:off x="4937760" y="3255264"/>
+            <a:ext cx="3611880" cy="256032"/>
+          </a:xfrm>
+          <a:prstGeom prst="rect">
+            <a:avLst/>
+          </a:prstGeom>
+          <a:noFill/>
+          <a:ln/>
+        </p:spPr>
+        <p:txBody>
+          <a:bodyPr wrap="square" rtlCol="0" anchor="ctr"/>
+          <a:lstStyle/>
+          <a:p>
+            <a:pPr indent="0" marL="0">
+              <a:buNone/>
+            </a:pPr>
+            <a:r>
+              <a:rPr lang="en-US" sz="920" b="1" dirty="0">
+                <a:solidFill>
+                  <a:srgbClr val="B06000"/>
+                </a:solidFill>
+                <a:latin typeface="Google Sans Display" pitchFamily="34" charset="0"/>
+                <a:ea typeface="Google Sans Display" pitchFamily="34" charset="-122"/>
+                <a:cs typeface="Google Sans Display" pitchFamily="34" charset="-120"/>
+              </a:rPr>
+              <a:t>Tenant Beta • RetailStream Corp (Shared Pool)</a:t>
+            </a:r>
+            <a:endParaRPr lang="en-US" sz="920" dirty="0"/>
+          </a:p>
+        </p:txBody>
+      </p:sp>
+      <p:sp>
+        <p:nvSpPr>
+          <p:cNvPr id="51" name="Shape 49"/>
+          <p:cNvSpPr/>
+          <p:nvPr/>
+        </p:nvSpPr>
+        <p:spPr>
+          <a:xfrm>
+            <a:off x="4956048" y="3602736"/>
+            <a:ext cx="3575304" cy="493776"/>
+          </a:xfrm>
+          <a:prstGeom prst="roundRect">
+            <a:avLst>
+              <a:gd name="adj" fmla="val 11111"/>
+            </a:avLst>
+          </a:prstGeom>
+          <a:solidFill>
+            <a:srgbClr val="FFFFFF"/>
+          </a:solidFill>
+          <a:ln w="11430">
+            <a:solidFill>
+              <a:srgbClr val="B06000"/>
+            </a:solidFill>
+            <a:prstDash val="solid"/>
+          </a:ln>
+        </p:spPr>
+      </p:sp>
+      <p:sp>
+        <p:nvSpPr>
+          <p:cNvPr id="52" name="Text 50"/>
+          <p:cNvSpPr/>
+          <p:nvPr/>
+        </p:nvSpPr>
+        <p:spPr>
+          <a:xfrm>
+            <a:off x="5065776" y="3602736"/>
+            <a:ext cx="3355848" cy="493776"/>
+          </a:xfrm>
+          <a:prstGeom prst="rect">
+            <a:avLst/>
+          </a:prstGeom>
+          <a:noFill/>
+          <a:ln/>
+        </p:spPr>
+        <p:txBody>
+          <a:bodyPr wrap="square" rtlCol="0" anchor="ctr"/>
+          <a:lstStyle/>
+          <a:p>
+            <a:pPr indent="0" marL="0">
+              <a:buNone/>
+            </a:pPr>
+            <a:r>
+              <a:rPr lang="en-US" sz="860" b="1" dirty="0">
+                <a:solidFill>
+                  <a:srgbClr val="0F172A"/>
+                </a:solidFill>
+                <a:latin typeface="Google Sans Text" pitchFamily="34" charset="0"/>
+                <a:ea typeface="Google Sans Text" pitchFamily="34" charset="-122"/>
+                <a:cs typeface="Google Sans Text" pitchFamily="34" charset="-120"/>
+              </a:rPr>
+              <a:t>• JWT Claim: tenant_id="retailstream", tier="STANDARD"</a:t>
+            </a:r>
+            <a:endParaRPr lang="en-US" sz="860" dirty="0"/>
+          </a:p>
+        </p:txBody>
+      </p:sp>
+      <p:sp>
+        <p:nvSpPr>
+          <p:cNvPr id="53" name="Shape 51"/>
+          <p:cNvSpPr/>
+          <p:nvPr/>
+        </p:nvSpPr>
+        <p:spPr>
+          <a:xfrm>
+            <a:off x="4956048" y="4224528"/>
+            <a:ext cx="3575304" cy="493776"/>
+          </a:xfrm>
+          <a:prstGeom prst="roundRect">
+            <a:avLst>
+              <a:gd name="adj" fmla="val 11111"/>
+            </a:avLst>
+          </a:prstGeom>
+          <a:solidFill>
+            <a:srgbClr val="FFFFFF"/>
+          </a:solidFill>
+          <a:ln w="11430">
+            <a:solidFill>
+              <a:srgbClr val="B06000"/>
+            </a:solidFill>
+            <a:prstDash val="solid"/>
+          </a:ln>
+        </p:spPr>
+      </p:sp>
+      <p:sp>
+        <p:nvSpPr>
+          <p:cNvPr id="54" name="Text 52"/>
+          <p:cNvSpPr/>
+          <p:nvPr/>
+        </p:nvSpPr>
+        <p:spPr>
+          <a:xfrm>
+            <a:off x="5065776" y="4224528"/>
+            <a:ext cx="3355848" cy="493776"/>
+          </a:xfrm>
+          <a:prstGeom prst="rect">
+            <a:avLst/>
+          </a:prstGeom>
+          <a:noFill/>
+          <a:ln/>
+        </p:spPr>
+        <p:txBody>
+          <a:bodyPr wrap="square" rtlCol="0" anchor="ctr"/>
+          <a:lstStyle/>
+          <a:p>
+            <a:pPr indent="0" marL="0">
+              <a:buNone/>
+            </a:pPr>
+            <a:r>
+              <a:rPr lang="en-US" sz="860" b="1" dirty="0">
+                <a:solidFill>
+                  <a:srgbClr val="0F172A"/>
+                </a:solidFill>
+                <a:latin typeface="Google Sans Text" pitchFamily="34" charset="0"/>
+                <a:ea typeface="Google Sans Text" pitchFamily="34" charset="-122"/>
+                <a:cs typeface="Google Sans Text" pitchFamily="34" charset="-120"/>
+              </a:rPr>
+              <a:t>• Agent Engine: Shared Diagnostic + 32k Prefix Cache</a:t>
+            </a:r>
+            <a:endParaRPr lang="en-US" sz="860" dirty="0"/>
+          </a:p>
+        </p:txBody>
+      </p:sp>
+      <p:sp>
+        <p:nvSpPr>
+          <p:cNvPr id="55" name="Shape 53"/>
+          <p:cNvSpPr/>
+          <p:nvPr/>
+        </p:nvSpPr>
+        <p:spPr>
+          <a:xfrm>
+            <a:off x="4956048" y="4846320"/>
+            <a:ext cx="3575304" cy="493776"/>
+          </a:xfrm>
+          <a:prstGeom prst="roundRect">
+            <a:avLst>
+              <a:gd name="adj" fmla="val 11111"/>
+            </a:avLst>
+          </a:prstGeom>
+          <a:solidFill>
+            <a:srgbClr val="FFFFFF"/>
+          </a:solidFill>
+          <a:ln w="11430">
+            <a:solidFill>
+              <a:srgbClr val="B06000"/>
+            </a:solidFill>
+            <a:prstDash val="solid"/>
+          </a:ln>
+        </p:spPr>
+      </p:sp>
+      <p:sp>
+        <p:nvSpPr>
+          <p:cNvPr id="56" name="Text 54"/>
+          <p:cNvSpPr/>
+          <p:nvPr/>
+        </p:nvSpPr>
+        <p:spPr>
+          <a:xfrm>
+            <a:off x="5065776" y="4846320"/>
+            <a:ext cx="3355848" cy="493776"/>
+          </a:xfrm>
+          <a:prstGeom prst="rect">
+            <a:avLst/>
+          </a:prstGeom>
+          <a:noFill/>
+          <a:ln/>
+        </p:spPr>
+        <p:txBody>
+          <a:bodyPr wrap="square" rtlCol="0" anchor="ctr"/>
+          <a:lstStyle/>
+          <a:p>
+            <a:pPr indent="0" marL="0">
+              <a:buNone/>
+            </a:pPr>
+            <a:r>
+              <a:rPr lang="en-US" sz="860" b="1" dirty="0">
+                <a:solidFill>
+                  <a:srgbClr val="0F172A"/>
+                </a:solidFill>
+                <a:latin typeface="Google Sans Text" pitchFamily="34" charset="0"/>
+                <a:ea typeface="Google Sans Text" pitchFamily="34" charset="-122"/>
+                <a:cs typeface="Google Sans Text" pitchFamily="34" charset="-120"/>
+              </a:rPr>
+              <a:t>• MCP Tools: SharePoint + ServiceNow 3LO Vault</a:t>
+            </a:r>
+            <a:endParaRPr lang="en-US" sz="860" dirty="0"/>
+          </a:p>
+        </p:txBody>
+      </p:sp>
+      <p:sp>
+        <p:nvSpPr>
+          <p:cNvPr id="57" name="Shape 55"/>
+          <p:cNvSpPr/>
+          <p:nvPr/>
+        </p:nvSpPr>
+        <p:spPr>
+          <a:xfrm>
+            <a:off x="4956048" y="5468112"/>
+            <a:ext cx="3575304" cy="493776"/>
+          </a:xfrm>
+          <a:prstGeom prst="roundRect">
+            <a:avLst>
+              <a:gd name="adj" fmla="val 11111"/>
+            </a:avLst>
+          </a:prstGeom>
+          <a:solidFill>
+            <a:srgbClr val="FFFFFF"/>
+          </a:solidFill>
+          <a:ln w="11430">
+            <a:solidFill>
+              <a:srgbClr val="B06000"/>
+            </a:solidFill>
+            <a:prstDash val="solid"/>
+          </a:ln>
+        </p:spPr>
+      </p:sp>
+      <p:sp>
+        <p:nvSpPr>
+          <p:cNvPr id="58" name="Text 56"/>
+          <p:cNvSpPr/>
+          <p:nvPr/>
+        </p:nvSpPr>
+        <p:spPr>
+          <a:xfrm>
+            <a:off x="5065776" y="5468112"/>
+            <a:ext cx="3355848" cy="493776"/>
+          </a:xfrm>
+          <a:prstGeom prst="rect">
+            <a:avLst/>
+          </a:prstGeom>
+          <a:noFill/>
+          <a:ln/>
+        </p:spPr>
+        <p:txBody>
+          <a:bodyPr wrap="square" rtlCol="0" anchor="ctr"/>
+          <a:lstStyle/>
+          <a:p>
+            <a:pPr indent="0" marL="0">
+              <a:buNone/>
+            </a:pPr>
+            <a:r>
+              <a:rPr lang="en-US" sz="860" b="1" dirty="0">
+                <a:solidFill>
+                  <a:srgbClr val="0F172A"/>
+                </a:solidFill>
+                <a:latin typeface="Google Sans Text" pitchFamily="34" charset="0"/>
+                <a:ea typeface="Google Sans Text" pitchFamily="34" charset="-122"/>
+                <a:cs typeface="Google Sans Text" pitchFamily="34" charset="-120"/>
+              </a:rPr>
+              <a:t>• Datastore: Pooled AlloyDB FORCE ROW SECURITY</a:t>
+            </a:r>
+            <a:endParaRPr lang="en-US" sz="860" dirty="0"/>
+          </a:p>
+        </p:txBody>
+      </p:sp>
+      <p:sp>
+        <p:nvSpPr>
+          <p:cNvPr id="59" name="Shape 57"/>
           <p:cNvSpPr/>
           <p:nvPr/>
         </p:nvSpPr>
@@ -21844,7 +25333,7 @@
       </p:sp>
       <p:sp>
         <p:nvSpPr>
-          <p:cNvPr id="19" name="Shape 16"/>
+          <p:cNvPr id="60" name="Shape 58"/>
           <p:cNvSpPr/>
           <p:nvPr/>
         </p:nvSpPr>
@@ -21869,7 +25358,7 @@
       </p:sp>
       <p:sp>
         <p:nvSpPr>
-          <p:cNvPr id="20" name="Text 17"/>
+          <p:cNvPr id="61" name="Text 59"/>
           <p:cNvSpPr/>
           <p:nvPr/>
         </p:nvSpPr>
@@ -21908,7 +25397,7 @@
       </p:sp>
       <p:sp>
         <p:nvSpPr>
-          <p:cNvPr id="21" name="Text 18"/>
+          <p:cNvPr id="62" name="Text 60"/>
           <p:cNvSpPr/>
           <p:nvPr/>
         </p:nvSpPr>
@@ -21947,7 +25436,7 @@
       </p:sp>
       <p:sp>
         <p:nvSpPr>
-          <p:cNvPr id="22" name="Shape 19"/>
+          <p:cNvPr id="63" name="Shape 61"/>
           <p:cNvSpPr/>
           <p:nvPr/>
         </p:nvSpPr>
@@ -21974,7 +25463,7 @@
       </p:sp>
       <p:sp>
         <p:nvSpPr>
-          <p:cNvPr id="23" name="Shape 20"/>
+          <p:cNvPr id="64" name="Shape 62"/>
           <p:cNvSpPr/>
           <p:nvPr/>
         </p:nvSpPr>
@@ -21999,7 +25488,7 @@
       </p:sp>
       <p:sp>
         <p:nvSpPr>
-          <p:cNvPr id="24" name="Text 21"/>
+          <p:cNvPr id="65" name="Text 63"/>
           <p:cNvSpPr/>
           <p:nvPr/>
         </p:nvSpPr>
@@ -22038,7 +25527,7 @@
       </p:sp>
       <p:sp>
         <p:nvSpPr>
-          <p:cNvPr id="25" name="Text 22"/>
+          <p:cNvPr id="66" name="Text 64"/>
           <p:cNvSpPr/>
           <p:nvPr/>
         </p:nvSpPr>
@@ -22077,7 +25566,7 @@
       </p:sp>
       <p:sp>
         <p:nvSpPr>
-          <p:cNvPr id="26" name="Shape 23"/>
+          <p:cNvPr id="67" name="Shape 65"/>
           <p:cNvSpPr/>
           <p:nvPr/>
         </p:nvSpPr>
@@ -22104,7 +25593,7 @@
       </p:sp>
       <p:sp>
         <p:nvSpPr>
-          <p:cNvPr id="27" name="Shape 24"/>
+          <p:cNvPr id="68" name="Shape 66"/>
           <p:cNvSpPr/>
           <p:nvPr/>
         </p:nvSpPr>
@@ -22129,7 +25618,7 @@
       </p:sp>
       <p:sp>
         <p:nvSpPr>
-          <p:cNvPr id="28" name="Text 25"/>
+          <p:cNvPr id="69" name="Text 67"/>
           <p:cNvSpPr/>
           <p:nvPr/>
         </p:nvSpPr>
@@ -22168,7 +25657,7 @@
       </p:sp>
       <p:sp>
         <p:nvSpPr>
-          <p:cNvPr id="29" name="Text 26"/>
+          <p:cNvPr id="70" name="Text 68"/>
           <p:cNvSpPr/>
           <p:nvPr/>
         </p:nvSpPr>
@@ -22207,7 +25696,7 @@
       </p:sp>
       <p:sp>
         <p:nvSpPr>
-          <p:cNvPr id="30" name="Shape 27"/>
+          <p:cNvPr id="71" name="Shape 69"/>
           <p:cNvSpPr/>
           <p:nvPr/>
         </p:nvSpPr>
@@ -22234,7 +25723,7 @@
       </p:sp>
       <p:sp>
         <p:nvSpPr>
-          <p:cNvPr id="31" name="Shape 28"/>
+          <p:cNvPr id="72" name="Shape 70"/>
           <p:cNvSpPr/>
           <p:nvPr/>
         </p:nvSpPr>
@@ -22259,7 +25748,7 @@
       </p:sp>
       <p:sp>
         <p:nvSpPr>
-          <p:cNvPr id="32" name="Text 29"/>
+          <p:cNvPr id="73" name="Text 71"/>
           <p:cNvSpPr/>
           <p:nvPr/>
         </p:nvSpPr>
@@ -22298,7 +25787,7 @@
       </p:sp>
       <p:sp>
         <p:nvSpPr>
-          <p:cNvPr id="33" name="Text 30"/>
+          <p:cNvPr id="74" name="Text 72"/>
           <p:cNvSpPr/>
           <p:nvPr/>
         </p:nvSpPr>

</xml_diff>

<commit_message>
feat(ws1): embed real 100% decompiled editable DrawingML architecture diagrams on Slides 6 and 7 of ws1-12slide-visual-deck
</commit_message>
<xml_diff>
--- a/slides/ws1-blog1-executive-diagrams.pptx
+++ b/slides/ws1-blog1-executive-diagrams.pptx
@@ -2804,7 +2804,7 @@
               <a:srgbClr val="1A73E8"/>
             </a:solidFill>
             <a:prstDash val="solid"/>
-            <a:tailEnd type="arrow"/>
+            <a:tailEnd type="arrow" w="sm" len="sm"/>
           </a:ln>
         </p:spPr>
       </p:sp>
@@ -2999,7 +2999,7 @@
               <a:srgbClr val="1E8E3E"/>
             </a:solidFill>
             <a:prstDash val="solid"/>
-            <a:tailEnd type="arrow"/>
+            <a:tailEnd type="arrow" w="sm" len="sm"/>
           </a:ln>
         </p:spPr>
       </p:sp>
@@ -3194,7 +3194,7 @@
               <a:srgbClr val="B06000"/>
             </a:solidFill>
             <a:prstDash val="solid"/>
-            <a:tailEnd type="arrow"/>
+            <a:tailEnd type="arrow" w="sm" len="sm"/>
           </a:ln>
         </p:spPr>
       </p:sp>
@@ -4107,7 +4107,7 @@
               <a:srgbClr val="1A73E8"/>
             </a:solidFill>
             <a:prstDash val="solid"/>
-            <a:tailEnd type="arrow"/>
+            <a:tailEnd type="arrow" w="sm" len="sm"/>
           </a:ln>
         </p:spPr>
       </p:sp>
@@ -4197,7 +4197,7 @@
               <a:srgbClr val="1E8E3E"/>
             </a:solidFill>
             <a:prstDash val="solid"/>
-            <a:tailEnd type="arrow"/>
+            <a:tailEnd type="arrow" w="sm" len="sm"/>
           </a:ln>
         </p:spPr>
       </p:sp>
@@ -4353,7 +4353,7 @@
               <a:srgbClr val="1A73E8"/>
             </a:solidFill>
             <a:prstDash val="solid"/>
-            <a:tailEnd type="arrow"/>
+            <a:tailEnd type="arrow" w="sm" len="sm"/>
           </a:ln>
         </p:spPr>
       </p:sp>
@@ -4443,7 +4443,7 @@
               <a:srgbClr val="1E8E3E"/>
             </a:solidFill>
             <a:prstDash val="solid"/>
-            <a:tailEnd type="arrow"/>
+            <a:tailEnd type="arrow" w="sm" len="sm"/>
           </a:ln>
         </p:spPr>
       </p:sp>
@@ -4599,7 +4599,7 @@
               <a:srgbClr val="1A73E8"/>
             </a:solidFill>
             <a:prstDash val="solid"/>
-            <a:tailEnd type="arrow"/>
+            <a:tailEnd type="arrow" w="sm" len="sm"/>
           </a:ln>
         </p:spPr>
       </p:sp>
@@ -4689,7 +4689,7 @@
               <a:srgbClr val="1E8E3E"/>
             </a:solidFill>
             <a:prstDash val="solid"/>
-            <a:tailEnd type="arrow"/>
+            <a:tailEnd type="arrow" w="sm" len="sm"/>
           </a:ln>
         </p:spPr>
       </p:sp>
@@ -4845,7 +4845,7 @@
               <a:srgbClr val="1A73E8"/>
             </a:solidFill>
             <a:prstDash val="solid"/>
-            <a:tailEnd type="arrow"/>
+            <a:tailEnd type="arrow" w="sm" len="sm"/>
           </a:ln>
         </p:spPr>
       </p:sp>
@@ -4935,7 +4935,7 @@
               <a:srgbClr val="1E8E3E"/>
             </a:solidFill>
             <a:prstDash val="solid"/>
-            <a:tailEnd type="arrow"/>
+            <a:tailEnd type="arrow" w="sm" len="sm"/>
           </a:ln>
         </p:spPr>
       </p:sp>
@@ -5091,7 +5091,7 @@
               <a:srgbClr val="1A73E8"/>
             </a:solidFill>
             <a:prstDash val="solid"/>
-            <a:tailEnd type="arrow"/>
+            <a:tailEnd type="arrow" w="sm" len="sm"/>
           </a:ln>
         </p:spPr>
       </p:sp>
@@ -5181,7 +5181,7 @@
               <a:srgbClr val="1E8E3E"/>
             </a:solidFill>
             <a:prstDash val="solid"/>
-            <a:tailEnd type="arrow"/>
+            <a:tailEnd type="arrow" w="sm" len="sm"/>
           </a:ln>
         </p:spPr>
       </p:sp>
@@ -6379,7 +6379,7 @@
               <a:srgbClr val="1E8E3E"/>
             </a:solidFill>
             <a:prstDash val="solid"/>
-            <a:tailEnd type="arrow"/>
+            <a:tailEnd type="arrow" w="sm" len="sm"/>
           </a:ln>
         </p:spPr>
       </p:sp>
@@ -6589,7 +6589,7 @@
               <a:srgbClr val="1E8E3E"/>
             </a:solidFill>
             <a:prstDash val="solid"/>
-            <a:tailEnd type="arrow"/>
+            <a:tailEnd type="arrow" w="sm" len="sm"/>
           </a:ln>
         </p:spPr>
       </p:sp>
@@ -8057,7 +8057,7 @@
               <a:srgbClr val="1A73E8"/>
             </a:solidFill>
             <a:prstDash val="solid"/>
-            <a:tailEnd type="arrow"/>
+            <a:tailEnd type="arrow" w="sm" len="sm"/>
           </a:ln>
         </p:spPr>
       </p:sp>
@@ -8296,7 +8296,7 @@
               <a:srgbClr val="D93025"/>
             </a:solidFill>
             <a:prstDash val="solid"/>
-            <a:tailEnd type="arrow"/>
+            <a:tailEnd type="arrow" w="sm" len="sm"/>
           </a:ln>
         </p:spPr>
       </p:sp>
@@ -9246,7 +9246,7 @@
               <a:srgbClr val="D93025"/>
             </a:solidFill>
             <a:prstDash val="solid"/>
-            <a:tailEnd type="arrow"/>
+            <a:tailEnd type="arrow" w="sm" len="sm"/>
           </a:ln>
         </p:spPr>
       </p:sp>
@@ -9270,7 +9270,7 @@
               <a:srgbClr val="D93025"/>
             </a:solidFill>
             <a:prstDash val="solid"/>
-            <a:tailEnd type="arrow"/>
+            <a:tailEnd type="arrow" w="sm" len="sm"/>
           </a:ln>
         </p:spPr>
       </p:sp>
@@ -11652,7 +11652,7 @@
               <a:srgbClr val="1A73E8"/>
             </a:solidFill>
             <a:prstDash val="solid"/>
-            <a:tailEnd type="arrow"/>
+            <a:tailEnd type="arrow" w="sm" len="sm"/>
           </a:ln>
         </p:spPr>
       </p:sp>
@@ -11676,7 +11676,7 @@
               <a:srgbClr val="1A73E8"/>
             </a:solidFill>
             <a:prstDash val="solid"/>
-            <a:tailEnd type="arrow"/>
+            <a:tailEnd type="arrow" w="sm" len="sm"/>
           </a:ln>
         </p:spPr>
       </p:sp>
@@ -11700,7 +11700,7 @@
               <a:srgbClr val="1A73E8"/>
             </a:solidFill>
             <a:prstDash val="solid"/>
-            <a:tailEnd type="arrow"/>
+            <a:tailEnd type="arrow" w="sm" len="sm"/>
           </a:ln>
         </p:spPr>
       </p:sp>
@@ -11934,7 +11934,7 @@
               <a:srgbClr val="1A73E8"/>
             </a:solidFill>
             <a:prstDash val="solid"/>
-            <a:tailEnd type="arrow"/>
+            <a:tailEnd type="arrow" w="sm" len="sm"/>
           </a:ln>
         </p:spPr>
       </p:sp>
@@ -12102,7 +12102,7 @@
               <a:srgbClr val="1A73E8"/>
             </a:solidFill>
             <a:prstDash val="solid"/>
-            <a:tailEnd type="arrow"/>
+            <a:tailEnd type="arrow" w="sm" len="sm"/>
           </a:ln>
         </p:spPr>
       </p:sp>
@@ -12270,7 +12270,7 @@
               <a:srgbClr val="1A73E8"/>
             </a:solidFill>
             <a:prstDash val="solid"/>
-            <a:tailEnd type="arrow"/>
+            <a:tailEnd type="arrow" w="sm" len="sm"/>
           </a:ln>
         </p:spPr>
       </p:sp>
@@ -12438,7 +12438,7 @@
               <a:srgbClr val="1A73E8"/>
             </a:solidFill>
             <a:prstDash val="solid"/>
-            <a:tailEnd type="arrow"/>
+            <a:tailEnd type="arrow" w="sm" len="sm"/>
           </a:ln>
         </p:spPr>
       </p:sp>
@@ -12672,7 +12672,7 @@
               <a:srgbClr val="1E8E3E"/>
             </a:solidFill>
             <a:prstDash val="solid"/>
-            <a:tailEnd type="arrow"/>
+            <a:tailEnd type="arrow" w="sm" len="sm"/>
           </a:ln>
         </p:spPr>
       </p:sp>
@@ -12696,7 +12696,7 @@
               <a:srgbClr val="1E8E3E"/>
             </a:solidFill>
             <a:prstDash val="solid"/>
-            <a:tailEnd type="arrow"/>
+            <a:tailEnd type="arrow" w="sm" len="sm"/>
           </a:ln>
         </p:spPr>
       </p:sp>
@@ -12720,7 +12720,7 @@
               <a:srgbClr val="1E8E3E"/>
             </a:solidFill>
             <a:prstDash val="solid"/>
-            <a:tailEnd type="arrow"/>
+            <a:tailEnd type="arrow" w="sm" len="sm"/>
           </a:ln>
         </p:spPr>
       </p:sp>
@@ -13925,7 +13925,7 @@
               <a:srgbClr val="1A73E8"/>
             </a:solidFill>
             <a:prstDash val="solid"/>
-            <a:tailEnd type="arrow"/>
+            <a:tailEnd type="arrow" w="sm" len="sm"/>
           </a:ln>
         </p:spPr>
       </p:sp>
@@ -14169,7 +14169,7 @@
               <a:srgbClr val="1A73E8"/>
             </a:solidFill>
             <a:prstDash val="solid"/>
-            <a:tailEnd type="arrow"/>
+            <a:tailEnd type="arrow" w="sm" len="sm"/>
           </a:ln>
         </p:spPr>
       </p:sp>
@@ -14413,7 +14413,7 @@
               <a:srgbClr val="1E8E3E"/>
             </a:solidFill>
             <a:prstDash val="solid"/>
-            <a:tailEnd type="arrow"/>
+            <a:tailEnd type="arrow" w="sm" len="sm"/>
           </a:ln>
         </p:spPr>
       </p:sp>
@@ -14657,7 +14657,7 @@
               <a:srgbClr val="B06000"/>
             </a:solidFill>
             <a:prstDash val="solid"/>
-            <a:tailEnd type="arrow"/>
+            <a:tailEnd type="arrow" w="sm" len="sm"/>
           </a:ln>
         </p:spPr>
       </p:sp>
@@ -14901,7 +14901,7 @@
               <a:srgbClr val="D93025"/>
             </a:solidFill>
             <a:prstDash val="solid"/>
-            <a:tailEnd type="arrow"/>
+            <a:tailEnd type="arrow" w="sm" len="sm"/>
           </a:ln>
         </p:spPr>
       </p:sp>
@@ -15145,7 +15145,7 @@
               <a:srgbClr val="D93025"/>
             </a:solidFill>
             <a:prstDash val="solid"/>
-            <a:tailEnd type="arrow"/>
+            <a:tailEnd type="arrow" w="sm" len="sm"/>
           </a:ln>
         </p:spPr>
       </p:sp>
@@ -15169,7 +15169,7 @@
               <a:srgbClr val="D93025"/>
             </a:solidFill>
             <a:prstDash val="solid"/>
-            <a:tailEnd type="arrow"/>
+            <a:tailEnd type="arrow" w="sm" len="sm"/>
           </a:ln>
         </p:spPr>
       </p:sp>
@@ -15193,7 +15193,7 @@
               <a:srgbClr val="D93025"/>
             </a:solidFill>
             <a:prstDash val="solid"/>
-            <a:tailEnd type="arrow"/>
+            <a:tailEnd type="arrow" w="sm" len="sm"/>
           </a:ln>
         </p:spPr>
       </p:sp>
@@ -15217,7 +15217,7 @@
               <a:srgbClr val="D93025"/>
             </a:solidFill>
             <a:prstDash val="solid"/>
-            <a:tailEnd type="arrow"/>
+            <a:tailEnd type="arrow" w="sm" len="sm"/>
           </a:ln>
         </p:spPr>
       </p:sp>
@@ -16910,7 +16910,7 @@
               <a:srgbClr val="1A73E8"/>
             </a:solidFill>
             <a:prstDash val="solid"/>
-            <a:tailEnd type="arrow"/>
+            <a:tailEnd type="arrow" w="sm" len="sm"/>
           </a:ln>
         </p:spPr>
       </p:sp>
@@ -17507,7 +17507,7 @@
               <a:srgbClr val="1E8E3E"/>
             </a:solidFill>
             <a:prstDash val="solid"/>
-            <a:tailEnd type="arrow"/>
+            <a:tailEnd type="arrow" w="sm" len="sm"/>
           </a:ln>
         </p:spPr>
       </p:sp>
@@ -18635,7 +18635,7 @@
               <a:srgbClr val="1A73E8"/>
             </a:solidFill>
             <a:prstDash val="solid"/>
-            <a:tailEnd type="arrow"/>
+            <a:tailEnd type="arrow" w="sm" len="sm"/>
           </a:ln>
         </p:spPr>
       </p:sp>
@@ -18759,7 +18759,7 @@
               <a:srgbClr val="B06000"/>
             </a:solidFill>
             <a:prstDash val="solid"/>
-            <a:tailEnd type="arrow"/>
+            <a:tailEnd type="arrow" w="sm" len="sm"/>
           </a:ln>
         </p:spPr>
       </p:sp>
@@ -18919,7 +18919,7 @@
               <a:srgbClr val="D93025"/>
             </a:solidFill>
             <a:prstDash val="solid"/>
-            <a:tailEnd type="arrow"/>
+            <a:tailEnd type="arrow" w="sm" len="sm"/>
           </a:ln>
         </p:spPr>
       </p:sp>
@@ -18979,7 +18979,7 @@
               <a:srgbClr val="B06000"/>
             </a:solidFill>
             <a:prstDash val="solid"/>
-            <a:tailEnd type="arrow"/>
+            <a:tailEnd type="arrow" w="sm" len="sm"/>
           </a:ln>
         </p:spPr>
       </p:sp>
@@ -19039,7 +19039,7 @@
               <a:srgbClr val="1E8E3E"/>
             </a:solidFill>
             <a:prstDash val="solid"/>
-            <a:tailEnd type="arrow"/>
+            <a:tailEnd type="arrow" w="sm" len="sm"/>
           </a:ln>
         </p:spPr>
       </p:sp>
@@ -19063,7 +19063,7 @@
               <a:srgbClr val="1E8E3E"/>
             </a:solidFill>
             <a:prstDash val="solid"/>
-            <a:tailEnd type="arrow"/>
+            <a:tailEnd type="arrow" w="sm" len="sm"/>
           </a:ln>
         </p:spPr>
       </p:sp>
@@ -21389,7 +21389,7 @@
               <a:srgbClr val="1A73E8"/>
             </a:solidFill>
             <a:prstDash val="solid"/>
-            <a:tailEnd type="arrow"/>
+            <a:tailEnd type="arrow" w="sm" len="sm"/>
           </a:ln>
         </p:spPr>
       </p:sp>
@@ -21413,7 +21413,7 @@
               <a:srgbClr val="1A73E8"/>
             </a:solidFill>
             <a:prstDash val="solid"/>
-            <a:tailEnd type="arrow"/>
+            <a:tailEnd type="arrow" w="sm" len="sm"/>
           </a:ln>
         </p:spPr>
       </p:sp>
@@ -21437,7 +21437,7 @@
               <a:srgbClr val="1A73E8"/>
             </a:solidFill>
             <a:prstDash val="solid"/>
-            <a:tailEnd type="arrow"/>
+            <a:tailEnd type="arrow" w="sm" len="sm"/>
           </a:ln>
         </p:spPr>
       </p:sp>
@@ -21461,7 +21461,7 @@
               <a:srgbClr val="1A73E8"/>
             </a:solidFill>
             <a:prstDash val="solid"/>
-            <a:tailEnd type="arrow"/>
+            <a:tailEnd type="arrow" w="sm" len="sm"/>
           </a:ln>
         </p:spPr>
       </p:sp>
@@ -21485,7 +21485,7 @@
               <a:srgbClr val="1A73E8"/>
             </a:solidFill>
             <a:prstDash val="solid"/>
-            <a:tailEnd type="arrow"/>
+            <a:tailEnd type="arrow" w="sm" len="sm"/>
           </a:ln>
         </p:spPr>
       </p:sp>
@@ -21773,7 +21773,7 @@
               <a:srgbClr val="1E8E3E"/>
             </a:solidFill>
             <a:prstDash val="solid"/>
-            <a:tailEnd type="arrow"/>
+            <a:tailEnd type="arrow" w="sm" len="sm"/>
           </a:ln>
         </p:spPr>
       </p:sp>
@@ -21797,7 +21797,7 @@
               <a:srgbClr val="B06000"/>
             </a:solidFill>
             <a:prstDash val="solid"/>
-            <a:tailEnd type="arrow"/>
+            <a:tailEnd type="arrow" w="sm" len="sm"/>
           </a:ln>
         </p:spPr>
       </p:sp>
@@ -21821,7 +21821,7 @@
               <a:srgbClr val="D93025"/>
             </a:solidFill>
             <a:prstDash val="solid"/>
-            <a:tailEnd type="arrow"/>
+            <a:tailEnd type="arrow" w="sm" len="sm"/>
           </a:ln>
         </p:spPr>
       </p:sp>
@@ -22243,7 +22243,7 @@
               <a:srgbClr val="B06000"/>
             </a:solidFill>
             <a:prstDash val="solid"/>
-            <a:tailEnd type="arrow"/>
+            <a:tailEnd type="arrow" w="sm" len="sm"/>
           </a:ln>
         </p:spPr>
       </p:sp>
@@ -22267,7 +22267,7 @@
               <a:srgbClr val="B06000"/>
             </a:solidFill>
             <a:prstDash val="solid"/>
-            <a:tailEnd type="arrow"/>
+            <a:tailEnd type="arrow" w="sm" len="sm"/>
           </a:ln>
         </p:spPr>
       </p:sp>
@@ -22291,7 +22291,7 @@
               <a:srgbClr val="B06000"/>
             </a:solidFill>
             <a:prstDash val="solid"/>
-            <a:tailEnd type="arrow"/>
+            <a:tailEnd type="arrow" w="sm" len="sm"/>
           </a:ln>
         </p:spPr>
       </p:sp>
@@ -22713,7 +22713,7 @@
               <a:srgbClr val="D93025"/>
             </a:solidFill>
             <a:prstDash val="solid"/>
-            <a:tailEnd type="arrow"/>
+            <a:tailEnd type="arrow" w="sm" len="sm"/>
           </a:ln>
         </p:spPr>
       </p:sp>
@@ -22737,7 +22737,7 @@
               <a:srgbClr val="D93025"/>
             </a:solidFill>
             <a:prstDash val="solid"/>
-            <a:tailEnd type="arrow"/>
+            <a:tailEnd type="arrow" w="sm" len="sm"/>
           </a:ln>
         </p:spPr>
       </p:sp>
@@ -22761,7 +22761,7 @@
               <a:srgbClr val="D93025"/>
             </a:solidFill>
             <a:prstDash val="solid"/>
-            <a:tailEnd type="arrow"/>
+            <a:tailEnd type="arrow" w="sm" len="sm"/>
           </a:ln>
         </p:spPr>
       </p:sp>
@@ -23964,7 +23964,7 @@
               <a:srgbClr val="1A73E8"/>
             </a:solidFill>
             <a:prstDash val="solid"/>
-            <a:tailEnd type="arrow"/>
+            <a:tailEnd type="arrow" w="sm" len="sm"/>
           </a:ln>
         </p:spPr>
       </p:sp>
@@ -24127,7 +24127,7 @@
               <a:srgbClr val="1A73E8"/>
             </a:solidFill>
             <a:prstDash val="solid"/>
-            <a:tailEnd type="arrow"/>
+            <a:tailEnd type="arrow" w="sm" len="sm"/>
           </a:ln>
         </p:spPr>
       </p:sp>
@@ -24290,7 +24290,7 @@
               <a:srgbClr val="1E8E3E"/>
             </a:solidFill>
             <a:prstDash val="solid"/>
-            <a:tailEnd type="arrow"/>
+            <a:tailEnd type="arrow" w="sm" len="sm"/>
           </a:ln>
         </p:spPr>
       </p:sp>
@@ -24453,7 +24453,7 @@
               <a:srgbClr val="B06000"/>
             </a:solidFill>
             <a:prstDash val="solid"/>
-            <a:tailEnd type="arrow"/>
+            <a:tailEnd type="arrow" w="sm" len="sm"/>
           </a:ln>
         </p:spPr>
       </p:sp>
@@ -24616,7 +24616,7 @@
               <a:srgbClr val="D93025"/>
             </a:solidFill>
             <a:prstDash val="solid"/>
-            <a:tailEnd type="arrow"/>
+            <a:tailEnd type="arrow" w="sm" len="sm"/>
           </a:ln>
         </p:spPr>
       </p:sp>
@@ -24640,7 +24640,7 @@
               <a:srgbClr val="B06000"/>
             </a:solidFill>
             <a:prstDash val="solid"/>
-            <a:tailEnd type="arrow"/>
+            <a:tailEnd type="arrow" w="sm" len="sm"/>
           </a:ln>
         </p:spPr>
       </p:sp>
@@ -26743,7 +26743,7 @@
               <a:srgbClr val="1A73E8"/>
             </a:solidFill>
             <a:prstDash val="solid"/>
-            <a:tailEnd type="arrow"/>
+            <a:tailEnd type="arrow" w="sm" len="sm"/>
           </a:ln>
         </p:spPr>
       </p:sp>
@@ -26833,7 +26833,7 @@
               <a:srgbClr val="1A73E8"/>
             </a:solidFill>
             <a:prstDash val="solid"/>
-            <a:tailEnd type="arrow"/>
+            <a:tailEnd type="arrow" w="sm" len="sm"/>
           </a:ln>
         </p:spPr>
       </p:sp>
@@ -26923,7 +26923,7 @@
               <a:srgbClr val="1E8E3E"/>
             </a:solidFill>
             <a:prstDash val="solid"/>
-            <a:tailEnd type="arrow"/>
+            <a:tailEnd type="arrow" w="sm" len="sm"/>
           </a:ln>
         </p:spPr>
       </p:sp>
@@ -27013,7 +27013,7 @@
               <a:srgbClr val="B06000"/>
             </a:solidFill>
             <a:prstDash val="solid"/>
-            <a:tailEnd type="arrow"/>
+            <a:tailEnd type="arrow" w="sm" len="sm"/>
           </a:ln>
         </p:spPr>
       </p:sp>
@@ -27103,7 +27103,7 @@
               <a:srgbClr val="1E8E3E"/>
             </a:solidFill>
             <a:prstDash val="solid"/>
-            <a:headEnd type="arrow"/>
+            <a:headEnd type="arrow" w="sm" len="sm"/>
           </a:ln>
         </p:spPr>
       </p:sp>

</xml_diff>